<commit_message>
presentation: deliver ten-slide editable deck and six-minute animated MP4
</commit_message>
<xml_diff>
--- a/presentation/nckh_defense/script_first_v3/final_10_slide_v1/NCKH_Ensemble_IDS_10_Slides_Final.pptx
+++ b/presentation/nckh_defense/script_first_v3/final_10_slide_v1/NCKH_Ensemble_IDS_10_Slides_Final.pptx
@@ -3936,8 +3936,8 @@
         </p:blipFill>
         <p:spPr>
           <a:xfrm>
-            <a:off x="566928" y="640080"/>
-            <a:ext cx="1234440" cy="1234440"/>
+            <a:off x="10680192" y="438912"/>
+            <a:ext cx="777240" cy="777240"/>
           </a:xfrm>
           <a:prstGeom prst="rect">
             <a:avLst/>
@@ -3946,7 +3946,49 @@
       </p:pic>
       <p:sp>
         <p:nvSpPr>
-          <p:cNvPr id="25" name="Academy header"/>
+          <p:cNvPr id="25" name="White PTIT monogram"/>
+          <p:cNvSpPr txBox="1"/>
+          <p:nvPr/>
+        </p:nvSpPr>
+        <p:spPr>
+          <a:xfrm>
+            <a:off x="411480" y="3200400"/>
+            <a:ext cx="1600200" cy="777240"/>
+          </a:xfrm>
+          <a:prstGeom prst="rect">
+            <a:avLst/>
+          </a:prstGeom>
+          <a:noFill/>
+        </p:spPr>
+        <p:txBody>
+          <a:bodyPr wrap="square" lIns="0" rIns="0" tIns="0" bIns="0" anchor="ctr">
+            <a:spAutoFit/>
+          </a:bodyPr>
+          <a:lstStyle/>
+          <a:p>
+            <a:pPr>
+              <a:spcBef>
+                <a:spcPts val="0"/>
+              </a:spcBef>
+              <a:spcAft>
+                <a:spcPts val="0"/>
+              </a:spcAft>
+              <a:defRPr sz="3900" b="1">
+                <a:solidFill>
+                  <a:srgbClr val="F8F5EE"/>
+                </a:solidFill>
+                <a:latin typeface="Liberation Sans"/>
+              </a:defRPr>
+            </a:pPr>
+            <a:r>
+              <a:t>PTIT</a:t>
+            </a:r>
+          </a:p>
+        </p:txBody>
+      </p:sp>
+      <p:sp>
+        <p:nvSpPr>
+          <p:cNvPr id="26" name="Academy header"/>
           <p:cNvSpPr txBox="1"/>
           <p:nvPr/>
         </p:nvSpPr>
@@ -4007,7 +4049,7 @@
       </p:sp>
       <p:sp>
         <p:nvSpPr>
-          <p:cNvPr id="26" name="Research hero"/>
+          <p:cNvPr id="27" name="Research hero"/>
           <p:cNvSpPr txBox="1"/>
           <p:nvPr/>
         </p:nvSpPr>
@@ -4087,7 +4129,7 @@
       </p:sp>
       <p:sp>
         <p:nvSpPr>
-          <p:cNvPr id="27" name="Shape"/>
+          <p:cNvPr id="28" name="Shape"/>
           <p:cNvSpPr/>
           <p:nvPr/>
         </p:nvSpPr>
@@ -4130,7 +4172,7 @@
       </p:sp>
       <p:sp>
         <p:nvSpPr>
-          <p:cNvPr id="28" name="Official topic"/>
+          <p:cNvPr id="29" name="Official topic"/>
           <p:cNvSpPr txBox="1"/>
           <p:nvPr/>
         </p:nvSpPr>
@@ -4172,7 +4214,7 @@
       </p:sp>
       <p:sp>
         <p:nvSpPr>
-          <p:cNvPr id="29" name="Text"/>
+          <p:cNvPr id="30" name="Text"/>
           <p:cNvSpPr txBox="1"/>
           <p:nvPr/>
         </p:nvSpPr>
@@ -4214,7 +4256,7 @@
       </p:sp>
       <p:sp>
         <p:nvSpPr>
-          <p:cNvPr id="30" name="Text"/>
+          <p:cNvPr id="31" name="Text"/>
           <p:cNvSpPr txBox="1"/>
           <p:nvPr/>
         </p:nvSpPr>
@@ -4256,7 +4298,7 @@
       </p:sp>
       <p:sp>
         <p:nvSpPr>
-          <p:cNvPr id="31" name="Animated marker 1-0"/>
+          <p:cNvPr id="32" name="Animated marker 1-0"/>
           <p:cNvSpPr/>
           <p:nvPr/>
         </p:nvSpPr>
@@ -4299,7 +4341,7 @@
       </p:sp>
       <p:sp>
         <p:nvSpPr>
-          <p:cNvPr id="32" name="Animated marker 1-1"/>
+          <p:cNvPr id="33" name="Animated marker 1-1"/>
           <p:cNvSpPr/>
           <p:nvPr/>
         </p:nvSpPr>
@@ -4342,7 +4384,7 @@
       </p:sp>
       <p:sp>
         <p:nvSpPr>
-          <p:cNvPr id="33" name="Animated marker 1-2"/>
+          <p:cNvPr id="34" name="Animated marker 1-2"/>
           <p:cNvSpPr/>
           <p:nvPr/>
         </p:nvSpPr>
@@ -4385,7 +4427,7 @@
       </p:sp>
       <p:sp>
         <p:nvSpPr>
-          <p:cNvPr id="34" name="Animated marker 1-3"/>
+          <p:cNvPr id="35" name="Animated marker 1-3"/>
           <p:cNvSpPr/>
           <p:nvPr/>
         </p:nvSpPr>
@@ -4428,7 +4470,7 @@
       </p:sp>
       <p:sp>
         <p:nvSpPr>
-          <p:cNvPr id="35" name="Animated marker 1-4"/>
+          <p:cNvPr id="36" name="Animated marker 1-4"/>
           <p:cNvSpPr/>
           <p:nvPr/>
         </p:nvSpPr>
@@ -4471,7 +4513,7 @@
       </p:sp>
       <p:sp>
         <p:nvSpPr>
-          <p:cNvPr id="36" name="Animated marker 1-5"/>
+          <p:cNvPr id="37" name="Animated marker 1-5"/>
           <p:cNvSpPr/>
           <p:nvPr/>
         </p:nvSpPr>
@@ -4514,7 +4556,7 @@
       </p:sp>
       <p:sp>
         <p:nvSpPr>
-          <p:cNvPr id="37" name="Animated marker 1-6"/>
+          <p:cNvPr id="38" name="Animated marker 1-6"/>
           <p:cNvSpPr/>
           <p:nvPr/>
         </p:nvSpPr>
@@ -4557,7 +4599,7 @@
       </p:sp>
       <p:sp>
         <p:nvSpPr>
-          <p:cNvPr id="38" name="Animated marker 1-7"/>
+          <p:cNvPr id="39" name="Animated marker 1-7"/>
           <p:cNvSpPr/>
           <p:nvPr/>
         </p:nvSpPr>
@@ -4600,7 +4642,7 @@
       </p:sp>
       <p:sp>
         <p:nvSpPr>
-          <p:cNvPr id="39" name="Animated marker 1-8"/>
+          <p:cNvPr id="40" name="Animated marker 1-8"/>
           <p:cNvSpPr/>
           <p:nvPr/>
         </p:nvSpPr>
@@ -4643,7 +4685,7 @@
       </p:sp>
       <p:sp>
         <p:nvSpPr>
-          <p:cNvPr id="40" name="Animated marker 1-9"/>
+          <p:cNvPr id="41" name="Animated marker 1-9"/>
           <p:cNvSpPr/>
           <p:nvPr/>
         </p:nvSpPr>
@@ -4686,7 +4728,7 @@
       </p:sp>
       <p:sp>
         <p:nvSpPr>
-          <p:cNvPr id="41" name="Animated marker 1-10"/>
+          <p:cNvPr id="42" name="Animated marker 1-10"/>
           <p:cNvSpPr/>
           <p:nvPr/>
         </p:nvSpPr>
@@ -4729,7 +4771,7 @@
       </p:sp>
       <p:sp>
         <p:nvSpPr>
-          <p:cNvPr id="42" name="Animated marker 1-11"/>
+          <p:cNvPr id="43" name="Animated marker 1-11"/>
           <p:cNvSpPr/>
           <p:nvPr/>
         </p:nvSpPr>
@@ -4772,7 +4814,7 @@
       </p:sp>
       <p:sp>
         <p:nvSpPr>
-          <p:cNvPr id="43" name="Animated marker 1-12"/>
+          <p:cNvPr id="44" name="Animated marker 1-12"/>
           <p:cNvSpPr/>
           <p:nvPr/>
         </p:nvSpPr>
@@ -4815,7 +4857,7 @@
       </p:sp>
       <p:sp>
         <p:nvSpPr>
-          <p:cNvPr id="44" name="Animated marker 1-13"/>
+          <p:cNvPr id="45" name="Animated marker 1-13"/>
           <p:cNvSpPr/>
           <p:nvPr/>
         </p:nvSpPr>
@@ -4901,7 +4943,7 @@
                                           </p:stCondLst>
                                         </p:cTn>
                                         <p:tgtEl>
-                                          <p:spTgt spid="31"/>
+                                          <p:spTgt spid="32"/>
                                         </p:tgtEl>
                                         <p:attrNameLst>
                                           <p:attrName>style.visibility</p:attrName>
@@ -4915,7 +4957,7 @@
                                       <p:cBhvr additive="base">
                                         <p:cTn id="7" dur="850" fill="hold"/>
                                         <p:tgtEl>
-                                          <p:spTgt spid="31"/>
+                                          <p:spTgt spid="32"/>
                                         </p:tgtEl>
                                         <p:attrNameLst>
                                           <p:attrName>ppt_x</p:attrName>
@@ -4938,7 +4980,7 @@
                                       <p:cBhvr additive="base">
                                         <p:cTn id="8" dur="850" fill="hold"/>
                                         <p:tgtEl>
-                                          <p:spTgt spid="31"/>
+                                          <p:spTgt spid="32"/>
                                         </p:tgtEl>
                                         <p:attrNameLst>
                                           <p:attrName>ppt_y</p:attrName>
@@ -4974,7 +5016,7 @@
                                           </p:stCondLst>
                                         </p:cTn>
                                         <p:tgtEl>
-                                          <p:spTgt spid="32"/>
+                                          <p:spTgt spid="33"/>
                                         </p:tgtEl>
                                         <p:attrNameLst>
                                           <p:attrName>style.visibility</p:attrName>
@@ -4988,7 +5030,7 @@
                                       <p:cBhvr>
                                         <p:cTn id="11" dur="120"/>
                                         <p:tgtEl>
-                                          <p:spTgt spid="32"/>
+                                          <p:spTgt spid="33"/>
                                         </p:tgtEl>
                                       </p:cBhvr>
                                     </p:animEffect>
@@ -5009,7 +5051,7 @@
                                           </p:stCondLst>
                                         </p:cTn>
                                         <p:tgtEl>
-                                          <p:spTgt spid="32"/>
+                                          <p:spTgt spid="33"/>
                                         </p:tgtEl>
                                         <p:attrNameLst>
                                           <p:attrName>style.visibility</p:attrName>
@@ -5027,7 +5069,7 @@
                                           </p:stCondLst>
                                         </p:cTn>
                                         <p:tgtEl>
-                                          <p:spTgt spid="32"/>
+                                          <p:spTgt spid="33"/>
                                         </p:tgtEl>
                                         <p:attrNameLst>
                                           <p:attrName>ppt_x</p:attrName>
@@ -5052,7 +5094,7 @@
                                           </p:stCondLst>
                                         </p:cTn>
                                         <p:tgtEl>
-                                          <p:spTgt spid="33"/>
+                                          <p:spTgt spid="34"/>
                                         </p:tgtEl>
                                         <p:attrNameLst>
                                           <p:attrName>style.visibility</p:attrName>
@@ -5066,7 +5108,7 @@
                                       <p:cBhvr>
                                         <p:cTn id="17" dur="120"/>
                                         <p:tgtEl>
-                                          <p:spTgt spid="33"/>
+                                          <p:spTgt spid="34"/>
                                         </p:tgtEl>
                                       </p:cBhvr>
                                     </p:animEffect>
@@ -5087,7 +5129,7 @@
                                           </p:stCondLst>
                                         </p:cTn>
                                         <p:tgtEl>
-                                          <p:spTgt spid="33"/>
+                                          <p:spTgt spid="34"/>
                                         </p:tgtEl>
                                         <p:attrNameLst>
                                           <p:attrName>style.visibility</p:attrName>
@@ -5105,7 +5147,7 @@
                                           </p:stCondLst>
                                         </p:cTn>
                                         <p:tgtEl>
-                                          <p:spTgt spid="33"/>
+                                          <p:spTgt spid="34"/>
                                         </p:tgtEl>
                                         <p:attrNameLst>
                                           <p:attrName>ppt_x</p:attrName>
@@ -5130,7 +5172,7 @@
                                           </p:stCondLst>
                                         </p:cTn>
                                         <p:tgtEl>
-                                          <p:spTgt spid="34"/>
+                                          <p:spTgt spid="35"/>
                                         </p:tgtEl>
                                         <p:attrNameLst>
                                           <p:attrName>style.visibility</p:attrName>
@@ -5144,7 +5186,7 @@
                                       <p:cBhvr additive="base">
                                         <p:cTn id="23" dur="850" fill="hold"/>
                                         <p:tgtEl>
-                                          <p:spTgt spid="34"/>
+                                          <p:spTgt spid="35"/>
                                         </p:tgtEl>
                                         <p:attrNameLst>
                                           <p:attrName>ppt_x</p:attrName>
@@ -5167,7 +5209,7 @@
                                       <p:cBhvr additive="base">
                                         <p:cTn id="24" dur="850" fill="hold"/>
                                         <p:tgtEl>
-                                          <p:spTgt spid="34"/>
+                                          <p:spTgt spid="35"/>
                                         </p:tgtEl>
                                         <p:attrNameLst>
                                           <p:attrName>ppt_y</p:attrName>
@@ -5203,7 +5245,7 @@
                                           </p:stCondLst>
                                         </p:cTn>
                                         <p:tgtEl>
-                                          <p:spTgt spid="35"/>
+                                          <p:spTgt spid="36"/>
                                         </p:tgtEl>
                                         <p:attrNameLst>
                                           <p:attrName>style.visibility</p:attrName>
@@ -5217,7 +5259,7 @@
                                       <p:cBhvr>
                                         <p:cTn id="27" dur="120"/>
                                         <p:tgtEl>
-                                          <p:spTgt spid="35"/>
+                                          <p:spTgt spid="36"/>
                                         </p:tgtEl>
                                       </p:cBhvr>
                                     </p:animEffect>
@@ -5238,7 +5280,7 @@
                                           </p:stCondLst>
                                         </p:cTn>
                                         <p:tgtEl>
-                                          <p:spTgt spid="35"/>
+                                          <p:spTgt spid="36"/>
                                         </p:tgtEl>
                                         <p:attrNameLst>
                                           <p:attrName>style.visibility</p:attrName>
@@ -5256,7 +5298,7 @@
                                           </p:stCondLst>
                                         </p:cTn>
                                         <p:tgtEl>
-                                          <p:spTgt spid="35"/>
+                                          <p:spTgt spid="36"/>
                                         </p:tgtEl>
                                         <p:attrNameLst>
                                           <p:attrName>ppt_x</p:attrName>
@@ -5281,7 +5323,7 @@
                                           </p:stCondLst>
                                         </p:cTn>
                                         <p:tgtEl>
-                                          <p:spTgt spid="36"/>
+                                          <p:spTgt spid="37"/>
                                         </p:tgtEl>
                                         <p:attrNameLst>
                                           <p:attrName>style.visibility</p:attrName>
@@ -5299,7 +5341,7 @@
                                           </p:stCondLst>
                                         </p:cTn>
                                         <p:tgtEl>
-                                          <p:spTgt spid="36"/>
+                                          <p:spTgt spid="37"/>
                                         </p:tgtEl>
                                       </p:cBhvr>
                                       <p:from x="100000" y="100000"/>
@@ -5318,7 +5360,7 @@
                                       <p:cBhvr>
                                         <p:cTn id="35" dur="120"/>
                                         <p:tgtEl>
-                                          <p:spTgt spid="32"/>
+                                          <p:spTgt spid="33"/>
                                         </p:tgtEl>
                                       </p:cBhvr>
                                     </p:animEffect>
@@ -5330,7 +5372,7 @@
                                           </p:stCondLst>
                                         </p:cTn>
                                         <p:tgtEl>
-                                          <p:spTgt spid="32"/>
+                                          <p:spTgt spid="33"/>
                                         </p:tgtEl>
                                         <p:attrNameLst>
                                           <p:attrName>style.visibility</p:attrName>
@@ -5353,7 +5395,7 @@
                                       <p:cBhvr>
                                         <p:cTn id="38" dur="120"/>
                                         <p:tgtEl>
-                                          <p:spTgt spid="33"/>
+                                          <p:spTgt spid="34"/>
                                         </p:tgtEl>
                                       </p:cBhvr>
                                     </p:animEffect>
@@ -5365,7 +5407,7 @@
                                           </p:stCondLst>
                                         </p:cTn>
                                         <p:tgtEl>
-                                          <p:spTgt spid="33"/>
+                                          <p:spTgt spid="34"/>
                                         </p:tgtEl>
                                         <p:attrNameLst>
                                           <p:attrName>style.visibility</p:attrName>
@@ -5388,7 +5430,7 @@
                                       <p:cBhvr>
                                         <p:cTn id="41" dur="120"/>
                                         <p:tgtEl>
-                                          <p:spTgt spid="35"/>
+                                          <p:spTgt spid="36"/>
                                         </p:tgtEl>
                                       </p:cBhvr>
                                     </p:animEffect>
@@ -5400,7 +5442,7 @@
                                           </p:stCondLst>
                                         </p:cTn>
                                         <p:tgtEl>
-                                          <p:spTgt spid="35"/>
+                                          <p:spTgt spid="36"/>
                                         </p:tgtEl>
                                         <p:attrNameLst>
                                           <p:attrName>style.visibility</p:attrName>
@@ -14424,18 +14466,166 @@
           </a:p>
         </p:txBody>
       </p:sp>
-      <p:sp>
-        <p:nvSpPr>
-          <p:cNvPr id="10" name="Pipeline 1"/>
+      <p:cxnSp>
+        <p:nvCxnSpPr>
+          <p:cNvPr id="10" name="Flow connection 1"/>
+          <p:cNvCxnSpPr/>
+          <p:nvPr/>
+        </p:nvCxnSpPr>
+        <p:spPr>
+          <a:xfrm>
+            <a:off x="2075688" y="3886200"/>
+            <a:ext cx="914400" cy="0"/>
+          </a:xfrm>
+          <a:prstGeom prst="line">
+            <a:avLst/>
+          </a:prstGeom>
+          <a:ln w="50800">
+            <a:solidFill>
+              <a:srgbClr val="1EC4D2"/>
+            </a:solidFill>
+          </a:ln>
+        </p:spPr>
+        <p:style>
+          <a:lnRef idx="2">
+            <a:schemeClr val="accent1"/>
+          </a:lnRef>
+          <a:fillRef idx="0">
+            <a:schemeClr val="accent1"/>
+          </a:fillRef>
+          <a:effectRef idx="1">
+            <a:schemeClr val="accent1"/>
+          </a:effectRef>
+          <a:fontRef idx="minor">
+            <a:schemeClr val="tx1"/>
+          </a:fontRef>
+        </p:style>
+      </p:cxnSp>
+      <p:cxnSp>
+        <p:nvCxnSpPr>
+          <p:cNvPr id="11" name="Flow connection 2"/>
+          <p:cNvCxnSpPr/>
+          <p:nvPr/>
+        </p:nvCxnSpPr>
+        <p:spPr>
+          <a:xfrm>
+            <a:off x="4672584" y="3886200"/>
+            <a:ext cx="1371599" cy="0"/>
+          </a:xfrm>
+          <a:prstGeom prst="line">
+            <a:avLst/>
+          </a:prstGeom>
+          <a:ln w="50800">
+            <a:solidFill>
+              <a:srgbClr val="1EC4D2"/>
+            </a:solidFill>
+          </a:ln>
+        </p:spPr>
+        <p:style>
+          <a:lnRef idx="2">
+            <a:schemeClr val="accent1"/>
+          </a:lnRef>
+          <a:fillRef idx="0">
+            <a:schemeClr val="accent1"/>
+          </a:fillRef>
+          <a:effectRef idx="1">
+            <a:schemeClr val="accent1"/>
+          </a:effectRef>
+          <a:fontRef idx="minor">
+            <a:schemeClr val="tx1"/>
+          </a:fontRef>
+        </p:style>
+      </p:cxnSp>
+      <p:cxnSp>
+        <p:nvCxnSpPr>
+          <p:cNvPr id="12" name="Flow connection 3"/>
+          <p:cNvCxnSpPr/>
+          <p:nvPr/>
+        </p:nvCxnSpPr>
+        <p:spPr>
+          <a:xfrm>
+            <a:off x="7927847" y="3886200"/>
+            <a:ext cx="1609345" cy="0"/>
+          </a:xfrm>
+          <a:prstGeom prst="line">
+            <a:avLst/>
+          </a:prstGeom>
+          <a:ln w="50800">
+            <a:solidFill>
+              <a:srgbClr val="E62629"/>
+            </a:solidFill>
+          </a:ln>
+        </p:spPr>
+        <p:style>
+          <a:lnRef idx="2">
+            <a:schemeClr val="accent1"/>
+          </a:lnRef>
+          <a:fillRef idx="0">
+            <a:schemeClr val="accent1"/>
+          </a:fillRef>
+          <a:effectRef idx="1">
+            <a:schemeClr val="accent1"/>
+          </a:effectRef>
+          <a:fontRef idx="minor">
+            <a:schemeClr val="tx1"/>
+          </a:fontRef>
+        </p:style>
+      </p:cxnSp>
+      <p:sp>
+        <p:nvSpPr>
+          <p:cNvPr id="13" name="Scientific flow ring 0"/>
           <p:cNvSpPr/>
           <p:nvPr/>
         </p:nvSpPr>
         <p:spPr>
           <a:xfrm>
-            <a:off x="525780" y="3529584"/>
-            <a:ext cx="1508760" cy="841248"/>
-          </a:xfrm>
-          <a:prstGeom prst="roundRect">
+            <a:off x="832104" y="3319272"/>
+            <a:ext cx="1133856" cy="1133856"/>
+          </a:xfrm>
+          <a:prstGeom prst="ellipse">
+            <a:avLst/>
+          </a:prstGeom>
+          <a:noFill/>
+          <a:ln w="20320">
+            <a:solidFill>
+              <a:srgbClr val="1EC4D2"/>
+            </a:solidFill>
+          </a:ln>
+        </p:spPr>
+        <p:style>
+          <a:lnRef idx="1">
+            <a:schemeClr val="accent1"/>
+          </a:lnRef>
+          <a:fillRef idx="3">
+            <a:schemeClr val="accent1"/>
+          </a:fillRef>
+          <a:effectRef idx="2">
+            <a:schemeClr val="accent1"/>
+          </a:effectRef>
+          <a:fontRef idx="minor">
+            <a:schemeClr val="lt1"/>
+          </a:fontRef>
+        </p:style>
+        <p:txBody>
+          <a:bodyPr rtlCol="0" anchor="ctr"/>
+          <a:lstStyle/>
+          <a:p>
+            <a:pPr algn="ctr"/>
+          </a:p>
+        </p:txBody>
+      </p:sp>
+      <p:sp>
+        <p:nvSpPr>
+          <p:cNvPr id="14" name="Scientific flow inner 0"/>
+          <p:cNvSpPr/>
+          <p:nvPr/>
+        </p:nvSpPr>
+        <p:spPr>
+          <a:xfrm>
+            <a:off x="928481" y="3415649"/>
+            <a:ext cx="941100" cy="941100"/>
+          </a:xfrm>
+          <a:prstGeom prst="ellipse">
             <a:avLst/>
           </a:prstGeom>
           <a:solidFill>
@@ -14469,14 +14659,14 @@
       </p:sp>
       <p:sp>
         <p:nvSpPr>
-          <p:cNvPr id="11" name="Pipeline label 0"/>
+          <p:cNvPr id="15" name="Scientific stage 0"/>
           <p:cNvSpPr txBox="1"/>
           <p:nvPr/>
         </p:nvSpPr>
         <p:spPr>
           <a:xfrm>
-            <a:off x="617219" y="3675887"/>
-            <a:ext cx="1325880" cy="594360"/>
+            <a:off x="923544" y="3648090"/>
+            <a:ext cx="950976" cy="694944"/>
           </a:xfrm>
           <a:prstGeom prst="rect">
             <a:avLst/>
@@ -14489,7 +14679,7 @@
           </a:bodyPr>
           <a:lstStyle/>
           <a:p>
-            <a:pPr>
+            <a:pPr algn="ctr">
               <a:spcBef>
                 <a:spcPts val="0"/>
               </a:spcBef>
@@ -14511,16 +14701,59 @@
       </p:sp>
       <p:sp>
         <p:nvSpPr>
-          <p:cNvPr id="12" name="Pipeline 2"/>
+          <p:cNvPr id="16" name="Scientific flow ring 1"/>
           <p:cNvSpPr/>
           <p:nvPr/>
         </p:nvSpPr>
         <p:spPr>
           <a:xfrm>
-            <a:off x="2560320" y="3529584"/>
-            <a:ext cx="2194560" cy="841248"/>
-          </a:xfrm>
-          <a:prstGeom prst="roundRect">
+            <a:off x="3099816" y="3154680"/>
+            <a:ext cx="1463040" cy="1463040"/>
+          </a:xfrm>
+          <a:prstGeom prst="ellipse">
+            <a:avLst/>
+          </a:prstGeom>
+          <a:noFill/>
+          <a:ln w="20320">
+            <a:solidFill>
+              <a:srgbClr val="255E9E"/>
+            </a:solidFill>
+          </a:ln>
+        </p:spPr>
+        <p:style>
+          <a:lnRef idx="1">
+            <a:schemeClr val="accent1"/>
+          </a:lnRef>
+          <a:fillRef idx="3">
+            <a:schemeClr val="accent1"/>
+          </a:fillRef>
+          <a:effectRef idx="2">
+            <a:schemeClr val="accent1"/>
+          </a:effectRef>
+          <a:fontRef idx="minor">
+            <a:schemeClr val="lt1"/>
+          </a:fontRef>
+        </p:style>
+        <p:txBody>
+          <a:bodyPr rtlCol="0" anchor="ctr"/>
+          <a:lstStyle/>
+          <a:p>
+            <a:pPr algn="ctr"/>
+          </a:p>
+        </p:txBody>
+      </p:sp>
+      <p:sp>
+        <p:nvSpPr>
+          <p:cNvPr id="17" name="Scientific flow inner 1"/>
+          <p:cNvSpPr/>
+          <p:nvPr/>
+        </p:nvSpPr>
+        <p:spPr>
+          <a:xfrm>
+            <a:off x="3224174" y="3279038"/>
+            <a:ext cx="1214323" cy="1214323"/>
+          </a:xfrm>
+          <a:prstGeom prst="ellipse">
             <a:avLst/>
           </a:prstGeom>
           <a:solidFill>
@@ -14554,14 +14787,14 @@
       </p:sp>
       <p:sp>
         <p:nvSpPr>
-          <p:cNvPr id="13" name="Pipeline label 1"/>
+          <p:cNvPr id="18" name="Scientific stage 1"/>
           <p:cNvSpPr txBox="1"/>
           <p:nvPr/>
         </p:nvSpPr>
         <p:spPr>
           <a:xfrm>
-            <a:off x="2651760" y="3675887"/>
-            <a:ext cx="2011679" cy="594360"/>
+            <a:off x="3191256" y="3578961"/>
+            <a:ext cx="1280160" cy="694944"/>
           </a:xfrm>
           <a:prstGeom prst="rect">
             <a:avLst/>
@@ -14574,7 +14807,301 @@
           </a:bodyPr>
           <a:lstStyle/>
           <a:p>
-            <a:pPr>
+            <a:pPr algn="ctr">
+              <a:spcBef>
+                <a:spcPts val="0"/>
+              </a:spcBef>
+              <a:spcAft>
+                <a:spcPts val="0"/>
+              </a:spcAft>
+              <a:defRPr sz="1300" b="1">
+                <a:solidFill>
+                  <a:srgbClr val="F8F5EE"/>
+                </a:solidFill>
+                <a:latin typeface="Liberation Sans"/>
+              </a:defRPr>
+            </a:pPr>
+            <a:r>
+              <a:t>FEATURE</a:t>
+            </a:r>
+          </a:p>
+          <a:p>
+            <a:pPr algn="ctr">
+              <a:spcBef>
+                <a:spcPts val="0"/>
+              </a:spcBef>
+              <a:spcAft>
+                <a:spcPts val="0"/>
+              </a:spcAft>
+              <a:defRPr sz="1300" b="1">
+                <a:solidFill>
+                  <a:srgbClr val="F8F5EE"/>
+                </a:solidFill>
+                <a:latin typeface="Liberation Sans"/>
+              </a:defRPr>
+            </a:pPr>
+            <a:r>
+              <a:t>VECTOR</a:t>
+            </a:r>
+          </a:p>
+        </p:txBody>
+      </p:sp>
+      <p:sp>
+        <p:nvSpPr>
+          <p:cNvPr id="19" name="Scientific flow ring 2"/>
+          <p:cNvSpPr/>
+          <p:nvPr/>
+        </p:nvSpPr>
+        <p:spPr>
+          <a:xfrm>
+            <a:off x="6153912" y="3054096"/>
+            <a:ext cx="1664208" cy="1664208"/>
+          </a:xfrm>
+          <a:prstGeom prst="ellipse">
+            <a:avLst/>
+          </a:prstGeom>
+          <a:noFill/>
+          <a:ln w="20320">
+            <a:solidFill>
+              <a:srgbClr val="1EC4D2"/>
+            </a:solidFill>
+          </a:ln>
+        </p:spPr>
+        <p:style>
+          <a:lnRef idx="1">
+            <a:schemeClr val="accent1"/>
+          </a:lnRef>
+          <a:fillRef idx="3">
+            <a:schemeClr val="accent1"/>
+          </a:fillRef>
+          <a:effectRef idx="2">
+            <a:schemeClr val="accent1"/>
+          </a:effectRef>
+          <a:fontRef idx="minor">
+            <a:schemeClr val="lt1"/>
+          </a:fontRef>
+        </p:style>
+        <p:txBody>
+          <a:bodyPr rtlCol="0" anchor="ctr"/>
+          <a:lstStyle/>
+          <a:p>
+            <a:pPr algn="ctr"/>
+          </a:p>
+        </p:txBody>
+      </p:sp>
+      <p:sp>
+        <p:nvSpPr>
+          <p:cNvPr id="20" name="Scientific flow inner 2"/>
+          <p:cNvSpPr/>
+          <p:nvPr/>
+        </p:nvSpPr>
+        <p:spPr>
+          <a:xfrm>
+            <a:off x="6295369" y="3195553"/>
+            <a:ext cx="1381292" cy="1381292"/>
+          </a:xfrm>
+          <a:prstGeom prst="ellipse">
+            <a:avLst/>
+          </a:prstGeom>
+          <a:solidFill>
+            <a:srgbClr val="14192A"/>
+          </a:solidFill>
+          <a:ln>
+            <a:noFill/>
+          </a:ln>
+        </p:spPr>
+        <p:style>
+          <a:lnRef idx="1">
+            <a:schemeClr val="accent1"/>
+          </a:lnRef>
+          <a:fillRef idx="3">
+            <a:schemeClr val="accent1"/>
+          </a:fillRef>
+          <a:effectRef idx="2">
+            <a:schemeClr val="accent1"/>
+          </a:effectRef>
+          <a:fontRef idx="minor">
+            <a:schemeClr val="lt1"/>
+          </a:fontRef>
+        </p:style>
+        <p:txBody>
+          <a:bodyPr rtlCol="0" anchor="ctr"/>
+          <a:lstStyle/>
+          <a:p>
+            <a:pPr algn="ctr"/>
+          </a:p>
+        </p:txBody>
+      </p:sp>
+      <p:sp>
+        <p:nvSpPr>
+          <p:cNvPr id="21" name="Scientific stage 2"/>
+          <p:cNvSpPr txBox="1"/>
+          <p:nvPr/>
+        </p:nvSpPr>
+        <p:spPr>
+          <a:xfrm>
+            <a:off x="6245351" y="3536716"/>
+            <a:ext cx="1481328" cy="694944"/>
+          </a:xfrm>
+          <a:prstGeom prst="rect">
+            <a:avLst/>
+          </a:prstGeom>
+          <a:noFill/>
+        </p:spPr>
+        <p:txBody>
+          <a:bodyPr wrap="square" lIns="0" rIns="0" tIns="0" bIns="0" anchor="ctr">
+            <a:spAutoFit/>
+          </a:bodyPr>
+          <a:lstStyle/>
+          <a:p>
+            <a:pPr algn="ctr">
+              <a:spcBef>
+                <a:spcPts val="0"/>
+              </a:spcBef>
+              <a:spcAft>
+                <a:spcPts val="0"/>
+              </a:spcAft>
+              <a:defRPr sz="1300" b="1">
+                <a:solidFill>
+                  <a:srgbClr val="F8F5EE"/>
+                </a:solidFill>
+                <a:latin typeface="Liberation Sans"/>
+              </a:defRPr>
+            </a:pPr>
+            <a:r>
+              <a:t>BASE</a:t>
+            </a:r>
+          </a:p>
+          <a:p>
+            <a:pPr algn="ctr">
+              <a:spcBef>
+                <a:spcPts val="0"/>
+              </a:spcBef>
+              <a:spcAft>
+                <a:spcPts val="0"/>
+              </a:spcAft>
+              <a:defRPr sz="1300" b="1">
+                <a:solidFill>
+                  <a:srgbClr val="F8F5EE"/>
+                </a:solidFill>
+                <a:latin typeface="Liberation Sans"/>
+              </a:defRPr>
+            </a:pPr>
+            <a:r>
+              <a:t>LEARNERS</a:t>
+            </a:r>
+          </a:p>
+        </p:txBody>
+      </p:sp>
+      <p:sp>
+        <p:nvSpPr>
+          <p:cNvPr id="22" name="Scientific flow ring 3"/>
+          <p:cNvSpPr/>
+          <p:nvPr/>
+        </p:nvSpPr>
+        <p:spPr>
+          <a:xfrm>
+            <a:off x="9646920" y="3200400"/>
+            <a:ext cx="1371600" cy="1371600"/>
+          </a:xfrm>
+          <a:prstGeom prst="ellipse">
+            <a:avLst/>
+          </a:prstGeom>
+          <a:noFill/>
+          <a:ln w="20320">
+            <a:solidFill>
+              <a:srgbClr val="E62629"/>
+            </a:solidFill>
+          </a:ln>
+        </p:spPr>
+        <p:style>
+          <a:lnRef idx="1">
+            <a:schemeClr val="accent1"/>
+          </a:lnRef>
+          <a:fillRef idx="3">
+            <a:schemeClr val="accent1"/>
+          </a:fillRef>
+          <a:effectRef idx="2">
+            <a:schemeClr val="accent1"/>
+          </a:effectRef>
+          <a:fontRef idx="minor">
+            <a:schemeClr val="lt1"/>
+          </a:fontRef>
+        </p:style>
+        <p:txBody>
+          <a:bodyPr rtlCol="0" anchor="ctr"/>
+          <a:lstStyle/>
+          <a:p>
+            <a:pPr algn="ctr"/>
+          </a:p>
+        </p:txBody>
+      </p:sp>
+      <p:sp>
+        <p:nvSpPr>
+          <p:cNvPr id="23" name="Scientific flow inner 3"/>
+          <p:cNvSpPr/>
+          <p:nvPr/>
+        </p:nvSpPr>
+        <p:spPr>
+          <a:xfrm>
+            <a:off x="9763506" y="3316986"/>
+            <a:ext cx="1138428" cy="1138428"/>
+          </a:xfrm>
+          <a:prstGeom prst="ellipse">
+            <a:avLst/>
+          </a:prstGeom>
+          <a:solidFill>
+            <a:srgbClr val="E62629"/>
+          </a:solidFill>
+          <a:ln>
+            <a:noFill/>
+          </a:ln>
+        </p:spPr>
+        <p:style>
+          <a:lnRef idx="1">
+            <a:schemeClr val="accent1"/>
+          </a:lnRef>
+          <a:fillRef idx="3">
+            <a:schemeClr val="accent1"/>
+          </a:fillRef>
+          <a:effectRef idx="2">
+            <a:schemeClr val="accent1"/>
+          </a:effectRef>
+          <a:fontRef idx="minor">
+            <a:schemeClr val="lt1"/>
+          </a:fontRef>
+        </p:style>
+        <p:txBody>
+          <a:bodyPr rtlCol="0" anchor="ctr"/>
+          <a:lstStyle/>
+          <a:p>
+            <a:pPr algn="ctr"/>
+          </a:p>
+        </p:txBody>
+      </p:sp>
+      <p:sp>
+        <p:nvSpPr>
+          <p:cNvPr id="24" name="Scientific stage 3"/>
+          <p:cNvSpPr txBox="1"/>
+          <p:nvPr/>
+        </p:nvSpPr>
+        <p:spPr>
+          <a:xfrm>
+            <a:off x="9738360" y="3598164"/>
+            <a:ext cx="1188720" cy="694944"/>
+          </a:xfrm>
+          <a:prstGeom prst="rect">
+            <a:avLst/>
+          </a:prstGeom>
+          <a:noFill/>
+        </p:spPr>
+        <p:txBody>
+          <a:bodyPr wrap="square" lIns="0" rIns="0" tIns="0" bIns="0" anchor="ctr">
+            <a:spAutoFit/>
+          </a:bodyPr>
+          <a:lstStyle/>
+          <a:p>
+            <a:pPr algn="ctr">
               <a:spcBef>
                 <a:spcPts val="0"/>
               </a:spcBef>
@@ -14589,112 +15116,11 @@
               </a:defRPr>
             </a:pPr>
             <a:r>
-              <a:t>42 FEATURE</a:t>
+              <a:t>NORMAL</a:t>
             </a:r>
           </a:p>
-        </p:txBody>
-      </p:sp>
-      <p:cxnSp>
-        <p:nvCxnSpPr>
-          <p:cNvPr id="14" name="Pipe 1"/>
-          <p:cNvCxnSpPr/>
-          <p:nvPr/>
-        </p:nvCxnSpPr>
-        <p:spPr>
-          <a:xfrm>
-            <a:off x="2144268" y="3931920"/>
-            <a:ext cx="306323" cy="0"/>
-          </a:xfrm>
-          <a:prstGeom prst="line">
-            <a:avLst/>
-          </a:prstGeom>
-          <a:ln w="38100">
-            <a:solidFill>
-              <a:srgbClr val="1EC4D2"/>
-            </a:solidFill>
-          </a:ln>
-        </p:spPr>
-        <p:style>
-          <a:lnRef idx="2">
-            <a:schemeClr val="accent1"/>
-          </a:lnRef>
-          <a:fillRef idx="0">
-            <a:schemeClr val="accent1"/>
-          </a:fillRef>
-          <a:effectRef idx="1">
-            <a:schemeClr val="accent1"/>
-          </a:effectRef>
-          <a:fontRef idx="minor">
-            <a:schemeClr val="tx1"/>
-          </a:fontRef>
-        </p:style>
-      </p:cxnSp>
-      <p:sp>
-        <p:nvSpPr>
-          <p:cNvPr id="15" name="Pipeline 3"/>
-          <p:cNvSpPr/>
-          <p:nvPr/>
-        </p:nvSpPr>
-        <p:spPr>
-          <a:xfrm>
-            <a:off x="5509260" y="3529584"/>
-            <a:ext cx="2606040" cy="841248"/>
-          </a:xfrm>
-          <a:prstGeom prst="roundRect">
-            <a:avLst/>
-          </a:prstGeom>
-          <a:solidFill>
-            <a:srgbClr val="14192A"/>
-          </a:solidFill>
-          <a:ln>
-            <a:noFill/>
-          </a:ln>
-        </p:spPr>
-        <p:style>
-          <a:lnRef idx="1">
-            <a:schemeClr val="accent1"/>
-          </a:lnRef>
-          <a:fillRef idx="3">
-            <a:schemeClr val="accent1"/>
-          </a:fillRef>
-          <a:effectRef idx="2">
-            <a:schemeClr val="accent1"/>
-          </a:effectRef>
-          <a:fontRef idx="minor">
-            <a:schemeClr val="lt1"/>
-          </a:fontRef>
-        </p:style>
-        <p:txBody>
-          <a:bodyPr rtlCol="0" anchor="ctr"/>
-          <a:lstStyle/>
-          <a:p>
-            <a:pPr algn="ctr"/>
-          </a:p>
-        </p:txBody>
-      </p:sp>
-      <p:sp>
-        <p:nvSpPr>
-          <p:cNvPr id="16" name="Pipeline label 2"/>
-          <p:cNvSpPr txBox="1"/>
-          <p:nvPr/>
-        </p:nvSpPr>
-        <p:spPr>
-          <a:xfrm>
-            <a:off x="5600700" y="3675887"/>
-            <a:ext cx="2423160" cy="594360"/>
-          </a:xfrm>
-          <a:prstGeom prst="rect">
-            <a:avLst/>
-          </a:prstGeom>
-          <a:noFill/>
-        </p:spPr>
-        <p:txBody>
-          <a:bodyPr wrap="square" lIns="0" rIns="0" tIns="0" bIns="0" anchor="ctr">
-            <a:spAutoFit/>
-          </a:bodyPr>
-          <a:lstStyle/>
-          <a:p>
-            <a:pPr>
+          <a:p>
+            <a:pPr algn="ctr">
               <a:spcBef>
                 <a:spcPts val="0"/>
               </a:spcBef>
@@ -14709,28 +15135,113 @@
               </a:defRPr>
             </a:pPr>
             <a:r>
-              <a:t>BASE LEARNERS</a:t>
+              <a:t>/ ATTACK</a:t>
+            </a:r>
+          </a:p>
+        </p:txBody>
+      </p:sp>
+      <p:sp>
+        <p:nvSpPr>
+          <p:cNvPr id="25" name="Editable learner node"/>
+          <p:cNvSpPr/>
+          <p:nvPr/>
+        </p:nvSpPr>
+        <p:spPr>
+          <a:xfrm>
+            <a:off x="6163056" y="4910328"/>
+            <a:ext cx="384048" cy="384048"/>
+          </a:xfrm>
+          <a:prstGeom prst="ellipse">
+            <a:avLst/>
+          </a:prstGeom>
+          <a:solidFill>
+            <a:srgbClr val="1EC4D2"/>
+          </a:solidFill>
+          <a:ln>
+            <a:noFill/>
+          </a:ln>
+        </p:spPr>
+        <p:style>
+          <a:lnRef idx="1">
+            <a:schemeClr val="accent1"/>
+          </a:lnRef>
+          <a:fillRef idx="3">
+            <a:schemeClr val="accent1"/>
+          </a:fillRef>
+          <a:effectRef idx="2">
+            <a:schemeClr val="accent1"/>
+          </a:effectRef>
+          <a:fontRef idx="minor">
+            <a:schemeClr val="lt1"/>
+          </a:fontRef>
+        </p:style>
+        <p:txBody>
+          <a:bodyPr rtlCol="0" anchor="ctr"/>
+          <a:lstStyle/>
+          <a:p>
+            <a:pPr algn="ctr"/>
+          </a:p>
+        </p:txBody>
+      </p:sp>
+      <p:sp>
+        <p:nvSpPr>
+          <p:cNvPr id="26" name="Learner abbreviation"/>
+          <p:cNvSpPr txBox="1"/>
+          <p:nvPr/>
+        </p:nvSpPr>
+        <p:spPr>
+          <a:xfrm>
+            <a:off x="6199632" y="4983480"/>
+            <a:ext cx="320040" cy="201168"/>
+          </a:xfrm>
+          <a:prstGeom prst="rect">
+            <a:avLst/>
+          </a:prstGeom>
+          <a:noFill/>
+        </p:spPr>
+        <p:txBody>
+          <a:bodyPr wrap="square" lIns="0" rIns="0" tIns="0" bIns="0" anchor="ctr">
+            <a:spAutoFit/>
+          </a:bodyPr>
+          <a:lstStyle/>
+          <a:p>
+            <a:pPr algn="ctr">
+              <a:spcBef>
+                <a:spcPts val="0"/>
+              </a:spcBef>
+              <a:spcAft>
+                <a:spcPts val="0"/>
+              </a:spcAft>
+              <a:defRPr sz="1000" b="1">
+                <a:solidFill>
+                  <a:srgbClr val="14192A"/>
+                </a:solidFill>
+                <a:latin typeface="Liberation Sans"/>
+              </a:defRPr>
+            </a:pPr>
+            <a:r>
+              <a:t>LR</a:t>
             </a:r>
           </a:p>
         </p:txBody>
       </p:sp>
       <p:cxnSp>
         <p:nvCxnSpPr>
-          <p:cNvPr id="17" name="Pipe 2"/>
+          <p:cNvPr id="27" name="Connector"/>
           <p:cNvCxnSpPr/>
           <p:nvPr/>
         </p:nvCxnSpPr>
         <p:spPr>
-          <a:xfrm>
-            <a:off x="4864608" y="3931920"/>
-            <a:ext cx="534924" cy="0"/>
+          <a:xfrm flipV="1">
+            <a:off x="6345936" y="4791456"/>
+            <a:ext cx="640080" cy="91440"/>
           </a:xfrm>
           <a:prstGeom prst="line">
             <a:avLst/>
           </a:prstGeom>
-          <a:ln w="38100">
+          <a:ln w="10795">
             <a:solidFill>
-              <a:srgbClr val="1EC4D2"/>
+              <a:srgbClr val="778195"/>
             </a:solidFill>
           </a:ln>
         </p:spPr>
@@ -14751,20 +15262,20 @@
       </p:cxnSp>
       <p:sp>
         <p:nvSpPr>
-          <p:cNvPr id="18" name="Pipeline 4"/>
+          <p:cNvPr id="28" name="Editable learner node"/>
           <p:cNvSpPr/>
           <p:nvPr/>
         </p:nvSpPr>
         <p:spPr>
           <a:xfrm>
-            <a:off x="9121140" y="3529584"/>
-            <a:ext cx="2240280" cy="841248"/>
-          </a:xfrm>
-          <a:prstGeom prst="roundRect">
+            <a:off x="6986016" y="4910328"/>
+            <a:ext cx="384048" cy="384048"/>
+          </a:xfrm>
+          <a:prstGeom prst="ellipse">
             <a:avLst/>
           </a:prstGeom>
           <a:solidFill>
-            <a:srgbClr val="E62629"/>
+            <a:srgbClr val="8673E6"/>
           </a:solidFill>
           <a:ln>
             <a:noFill/>
@@ -14794,14 +15305,14 @@
       </p:sp>
       <p:sp>
         <p:nvSpPr>
-          <p:cNvPr id="19" name="Pipeline label 3"/>
+          <p:cNvPr id="29" name="Learner abbreviation"/>
           <p:cNvSpPr txBox="1"/>
           <p:nvPr/>
         </p:nvSpPr>
         <p:spPr>
           <a:xfrm>
-            <a:off x="9212580" y="3675887"/>
-            <a:ext cx="2057400" cy="594360"/>
+            <a:off x="7022592" y="4983480"/>
+            <a:ext cx="320040" cy="201168"/>
           </a:xfrm>
           <a:prstGeom prst="rect">
             <a:avLst/>
@@ -14814,43 +15325,43 @@
           </a:bodyPr>
           <a:lstStyle/>
           <a:p>
-            <a:pPr>
+            <a:pPr algn="ctr">
               <a:spcBef>
                 <a:spcPts val="0"/>
               </a:spcBef>
               <a:spcAft>
                 <a:spcPts val="0"/>
               </a:spcAft>
-              <a:defRPr sz="1400" b="1">
+              <a:defRPr sz="1000" b="1">
                 <a:solidFill>
-                  <a:srgbClr val="F8F5EE"/>
+                  <a:srgbClr val="14192A"/>
                 </a:solidFill>
                 <a:latin typeface="Liberation Sans"/>
               </a:defRPr>
             </a:pPr>
             <a:r>
-              <a:t>NORMAL / ATTACK</a:t>
+              <a:t>DT</a:t>
             </a:r>
           </a:p>
         </p:txBody>
       </p:sp>
       <p:cxnSp>
         <p:nvCxnSpPr>
-          <p:cNvPr id="20" name="Pipe 3"/>
+          <p:cNvPr id="30" name="Connector"/>
           <p:cNvCxnSpPr/>
           <p:nvPr/>
         </p:nvCxnSpPr>
         <p:spPr>
-          <a:xfrm>
-            <a:off x="8225027" y="3931920"/>
-            <a:ext cx="786385" cy="0"/>
+          <a:xfrm flipH="1" flipV="1">
+            <a:off x="6986016" y="4791456"/>
+            <a:ext cx="182880" cy="91440"/>
           </a:xfrm>
           <a:prstGeom prst="line">
             <a:avLst/>
           </a:prstGeom>
-          <a:ln w="38100">
+          <a:ln w="10795">
             <a:solidFill>
-              <a:srgbClr val="1EC4D2"/>
+              <a:srgbClr val="778195"/>
             </a:solidFill>
           </a:ln>
         </p:spPr>
@@ -14871,14 +15382,57 @@
       </p:cxnSp>
       <p:sp>
         <p:nvSpPr>
-          <p:cNvPr id="21" name="Text"/>
+          <p:cNvPr id="31" name="Editable learner node"/>
+          <p:cNvSpPr/>
+          <p:nvPr/>
+        </p:nvSpPr>
+        <p:spPr>
+          <a:xfrm>
+            <a:off x="7808976" y="4910328"/>
+            <a:ext cx="384048" cy="384048"/>
+          </a:xfrm>
+          <a:prstGeom prst="ellipse">
+            <a:avLst/>
+          </a:prstGeom>
+          <a:solidFill>
+            <a:srgbClr val="FF6A57"/>
+          </a:solidFill>
+          <a:ln>
+            <a:noFill/>
+          </a:ln>
+        </p:spPr>
+        <p:style>
+          <a:lnRef idx="1">
+            <a:schemeClr val="accent1"/>
+          </a:lnRef>
+          <a:fillRef idx="3">
+            <a:schemeClr val="accent1"/>
+          </a:fillRef>
+          <a:effectRef idx="2">
+            <a:schemeClr val="accent1"/>
+          </a:effectRef>
+          <a:fontRef idx="minor">
+            <a:schemeClr val="lt1"/>
+          </a:fontRef>
+        </p:style>
+        <p:txBody>
+          <a:bodyPr rtlCol="0" anchor="ctr"/>
+          <a:lstStyle/>
+          <a:p>
+            <a:pPr algn="ctr"/>
+          </a:p>
+        </p:txBody>
+      </p:sp>
+      <p:sp>
+        <p:nvSpPr>
+          <p:cNvPr id="32" name="Learner abbreviation"/>
           <p:cNvSpPr txBox="1"/>
           <p:nvPr/>
         </p:nvSpPr>
         <p:spPr>
           <a:xfrm>
-            <a:off x="5303520" y="4800600"/>
-            <a:ext cx="5760720" cy="548640"/>
+            <a:off x="7845552" y="4983480"/>
+            <a:ext cx="320040" cy="201168"/>
           </a:xfrm>
           <a:prstGeom prst="rect">
             <a:avLst/>
@@ -14891,36 +15445,71 @@
           </a:bodyPr>
           <a:lstStyle/>
           <a:p>
-            <a:pPr>
+            <a:pPr algn="ctr">
               <a:spcBef>
                 <a:spcPts val="0"/>
               </a:spcBef>
               <a:spcAft>
                 <a:spcPts val="0"/>
               </a:spcAft>
-              <a:defRPr sz="1200" b="1">
+              <a:defRPr sz="1000" b="1">
                 <a:solidFill>
-                  <a:srgbClr val="255E9E"/>
+                  <a:srgbClr val="14192A"/>
                 </a:solidFill>
                 <a:latin typeface="Liberation Sans"/>
               </a:defRPr>
             </a:pPr>
             <a:r>
-              <a:t>LOGISTIC REGRESSION  /  DECISION TREE  /  RANDOM FOREST</a:t>
+              <a:t>RF</a:t>
             </a:r>
           </a:p>
         </p:txBody>
       </p:sp>
-      <p:sp>
-        <p:nvSpPr>
-          <p:cNvPr id="22" name="Shape"/>
+      <p:cxnSp>
+        <p:nvCxnSpPr>
+          <p:cNvPr id="33" name="Connector"/>
+          <p:cNvCxnSpPr/>
+          <p:nvPr/>
+        </p:nvCxnSpPr>
+        <p:spPr>
+          <a:xfrm flipH="1" flipV="1">
+            <a:off x="6986016" y="4791456"/>
+            <a:ext cx="1005840" cy="91440"/>
+          </a:xfrm>
+          <a:prstGeom prst="line">
+            <a:avLst/>
+          </a:prstGeom>
+          <a:ln w="10795">
+            <a:solidFill>
+              <a:srgbClr val="778195"/>
+            </a:solidFill>
+          </a:ln>
+        </p:spPr>
+        <p:style>
+          <a:lnRef idx="2">
+            <a:schemeClr val="accent1"/>
+          </a:lnRef>
+          <a:fillRef idx="0">
+            <a:schemeClr val="accent1"/>
+          </a:fillRef>
+          <a:effectRef idx="1">
+            <a:schemeClr val="accent1"/>
+          </a:effectRef>
+          <a:fontRef idx="minor">
+            <a:schemeClr val="tx1"/>
+          </a:fontRef>
+        </p:style>
+      </p:cxnSp>
+      <p:sp>
+        <p:nvSpPr>
+          <p:cNvPr id="34" name="OOF label"/>
           <p:cNvSpPr/>
           <p:nvPr/>
         </p:nvSpPr>
         <p:spPr>
           <a:xfrm>
-            <a:off x="6281928" y="5532120"/>
-            <a:ext cx="3429000" cy="420624"/>
+            <a:off x="5961888" y="5532120"/>
+            <a:ext cx="3017520" cy="457200"/>
           </a:xfrm>
           <a:prstGeom prst="roundRect">
             <a:avLst/>
@@ -14956,14 +15545,14 @@
       </p:sp>
       <p:sp>
         <p:nvSpPr>
-          <p:cNvPr id="23" name="Text"/>
+          <p:cNvPr id="35" name="Text"/>
           <p:cNvSpPr txBox="1"/>
           <p:nvPr/>
         </p:nvSpPr>
         <p:spPr>
           <a:xfrm>
-            <a:off x="6473952" y="5577840"/>
-            <a:ext cx="3072384" cy="283464"/>
+            <a:off x="6126480" y="5596128"/>
+            <a:ext cx="2788920" cy="292608"/>
           </a:xfrm>
           <a:prstGeom prst="rect">
             <a:avLst/>
@@ -14998,14 +15587,14 @@
       </p:sp>
       <p:sp>
         <p:nvSpPr>
-          <p:cNvPr id="24" name="Flow point"/>
+          <p:cNvPr id="36" name="Editable flow particle"/>
           <p:cNvSpPr/>
           <p:nvPr/>
         </p:nvSpPr>
         <p:spPr>
           <a:xfrm>
-            <a:off x="2798064" y="3108960"/>
-            <a:ext cx="91440" cy="91440"/>
+            <a:off x="2395728" y="3044952"/>
+            <a:ext cx="68580" cy="68580"/>
           </a:xfrm>
           <a:prstGeom prst="ellipse">
             <a:avLst/>
@@ -15041,14 +15630,14 @@
       </p:sp>
       <p:sp>
         <p:nvSpPr>
-          <p:cNvPr id="25" name="Flow point"/>
+          <p:cNvPr id="37" name="Editable flow particle"/>
           <p:cNvSpPr/>
           <p:nvPr/>
         </p:nvSpPr>
         <p:spPr>
           <a:xfrm>
-            <a:off x="3099816" y="3108960"/>
-            <a:ext cx="91440" cy="91440"/>
+            <a:off x="2587752" y="3044952"/>
+            <a:ext cx="68580" cy="68580"/>
           </a:xfrm>
           <a:prstGeom prst="ellipse">
             <a:avLst/>
@@ -15084,14 +15673,14 @@
       </p:sp>
       <p:sp>
         <p:nvSpPr>
-          <p:cNvPr id="26" name="Flow point"/>
+          <p:cNvPr id="38" name="Editable flow particle"/>
           <p:cNvSpPr/>
           <p:nvPr/>
         </p:nvSpPr>
         <p:spPr>
           <a:xfrm>
-            <a:off x="3401568" y="3108960"/>
-            <a:ext cx="91440" cy="91440"/>
+            <a:off x="2779776" y="3044952"/>
+            <a:ext cx="68580" cy="68580"/>
           </a:xfrm>
           <a:prstGeom prst="ellipse">
             <a:avLst/>
@@ -15127,14 +15716,14 @@
       </p:sp>
       <p:sp>
         <p:nvSpPr>
-          <p:cNvPr id="27" name="Flow point"/>
+          <p:cNvPr id="39" name="Editable flow particle"/>
           <p:cNvSpPr/>
           <p:nvPr/>
         </p:nvSpPr>
         <p:spPr>
           <a:xfrm>
-            <a:off x="3703320" y="3108960"/>
-            <a:ext cx="91440" cy="91440"/>
+            <a:off x="2971800" y="3044952"/>
+            <a:ext cx="68580" cy="68580"/>
           </a:xfrm>
           <a:prstGeom prst="ellipse">
             <a:avLst/>
@@ -15170,14 +15759,14 @@
       </p:sp>
       <p:sp>
         <p:nvSpPr>
-          <p:cNvPr id="28" name="Flow point"/>
+          <p:cNvPr id="40" name="Editable flow particle"/>
           <p:cNvSpPr/>
           <p:nvPr/>
         </p:nvSpPr>
         <p:spPr>
           <a:xfrm>
-            <a:off x="4005072" y="3108960"/>
-            <a:ext cx="91440" cy="91440"/>
+            <a:off x="3163824" y="3044952"/>
+            <a:ext cx="68580" cy="68580"/>
           </a:xfrm>
           <a:prstGeom prst="ellipse">
             <a:avLst/>
@@ -15213,14 +15802,14 @@
       </p:sp>
       <p:sp>
         <p:nvSpPr>
-          <p:cNvPr id="29" name="Flow point"/>
+          <p:cNvPr id="41" name="Editable flow particle"/>
           <p:cNvSpPr/>
           <p:nvPr/>
         </p:nvSpPr>
         <p:spPr>
           <a:xfrm>
-            <a:off x="4306824" y="3108960"/>
-            <a:ext cx="91440" cy="91440"/>
+            <a:off x="3355848" y="3044952"/>
+            <a:ext cx="68580" cy="68580"/>
           </a:xfrm>
           <a:prstGeom prst="ellipse">
             <a:avLst/>
@@ -15256,14 +15845,14 @@
       </p:sp>
       <p:sp>
         <p:nvSpPr>
-          <p:cNvPr id="30" name="Flow point"/>
+          <p:cNvPr id="42" name="Editable flow particle"/>
           <p:cNvSpPr/>
           <p:nvPr/>
         </p:nvSpPr>
         <p:spPr>
           <a:xfrm>
-            <a:off x="4608576" y="3108960"/>
-            <a:ext cx="91440" cy="91440"/>
+            <a:off x="3547872" y="3044952"/>
+            <a:ext cx="68580" cy="68580"/>
           </a:xfrm>
           <a:prstGeom prst="ellipse">
             <a:avLst/>
@@ -15299,14 +15888,14 @@
       </p:sp>
       <p:sp>
         <p:nvSpPr>
-          <p:cNvPr id="31" name="Flow point"/>
+          <p:cNvPr id="43" name="Editable flow particle"/>
           <p:cNvSpPr/>
           <p:nvPr/>
         </p:nvSpPr>
         <p:spPr>
           <a:xfrm>
-            <a:off x="4910328" y="3108960"/>
-            <a:ext cx="91440" cy="91440"/>
+            <a:off x="3739896" y="3044952"/>
+            <a:ext cx="68580" cy="68580"/>
           </a:xfrm>
           <a:prstGeom prst="ellipse">
             <a:avLst/>
@@ -15342,7 +15931,93 @@
       </p:sp>
       <p:sp>
         <p:nvSpPr>
-          <p:cNvPr id="32" name="Animated marker 4-0"/>
+          <p:cNvPr id="44" name="Editable flow particle"/>
+          <p:cNvSpPr/>
+          <p:nvPr/>
+        </p:nvSpPr>
+        <p:spPr>
+          <a:xfrm>
+            <a:off x="3931920" y="3044952"/>
+            <a:ext cx="68580" cy="68580"/>
+          </a:xfrm>
+          <a:prstGeom prst="ellipse">
+            <a:avLst/>
+          </a:prstGeom>
+          <a:solidFill>
+            <a:srgbClr val="1EC4D2"/>
+          </a:solidFill>
+          <a:ln>
+            <a:noFill/>
+          </a:ln>
+        </p:spPr>
+        <p:style>
+          <a:lnRef idx="1">
+            <a:schemeClr val="accent1"/>
+          </a:lnRef>
+          <a:fillRef idx="3">
+            <a:schemeClr val="accent1"/>
+          </a:fillRef>
+          <a:effectRef idx="2">
+            <a:schemeClr val="accent1"/>
+          </a:effectRef>
+          <a:fontRef idx="minor">
+            <a:schemeClr val="lt1"/>
+          </a:fontRef>
+        </p:style>
+        <p:txBody>
+          <a:bodyPr rtlCol="0" anchor="ctr"/>
+          <a:lstStyle/>
+          <a:p>
+            <a:pPr algn="ctr"/>
+          </a:p>
+        </p:txBody>
+      </p:sp>
+      <p:sp>
+        <p:nvSpPr>
+          <p:cNvPr id="45" name="Editable flow particle"/>
+          <p:cNvSpPr/>
+          <p:nvPr/>
+        </p:nvSpPr>
+        <p:spPr>
+          <a:xfrm>
+            <a:off x="4123944" y="3044952"/>
+            <a:ext cx="68580" cy="68580"/>
+          </a:xfrm>
+          <a:prstGeom prst="ellipse">
+            <a:avLst/>
+          </a:prstGeom>
+          <a:solidFill>
+            <a:srgbClr val="1EC4D2"/>
+          </a:solidFill>
+          <a:ln>
+            <a:noFill/>
+          </a:ln>
+        </p:spPr>
+        <p:style>
+          <a:lnRef idx="1">
+            <a:schemeClr val="accent1"/>
+          </a:lnRef>
+          <a:fillRef idx="3">
+            <a:schemeClr val="accent1"/>
+          </a:fillRef>
+          <a:effectRef idx="2">
+            <a:schemeClr val="accent1"/>
+          </a:effectRef>
+          <a:fontRef idx="minor">
+            <a:schemeClr val="lt1"/>
+          </a:fontRef>
+        </p:style>
+        <p:txBody>
+          <a:bodyPr rtlCol="0" anchor="ctr"/>
+          <a:lstStyle/>
+          <a:p>
+            <a:pPr algn="ctr"/>
+          </a:p>
+        </p:txBody>
+      </p:sp>
+      <p:sp>
+        <p:nvSpPr>
+          <p:cNvPr id="46" name="Animated marker 4-0"/>
           <p:cNvSpPr/>
           <p:nvPr/>
         </p:nvSpPr>
@@ -15385,7 +16060,7 @@
       </p:sp>
       <p:sp>
         <p:nvSpPr>
-          <p:cNvPr id="33" name="Animated marker 4-1"/>
+          <p:cNvPr id="47" name="Animated marker 4-1"/>
           <p:cNvSpPr/>
           <p:nvPr/>
         </p:nvSpPr>
@@ -15428,7 +16103,7 @@
       </p:sp>
       <p:sp>
         <p:nvSpPr>
-          <p:cNvPr id="34" name="Animated marker 4-2"/>
+          <p:cNvPr id="48" name="Animated marker 4-2"/>
           <p:cNvSpPr/>
           <p:nvPr/>
         </p:nvSpPr>
@@ -15471,7 +16146,7 @@
       </p:sp>
       <p:sp>
         <p:nvSpPr>
-          <p:cNvPr id="35" name="Animated marker 4-3"/>
+          <p:cNvPr id="49" name="Animated marker 4-3"/>
           <p:cNvSpPr/>
           <p:nvPr/>
         </p:nvSpPr>
@@ -15514,7 +16189,7 @@
       </p:sp>
       <p:sp>
         <p:nvSpPr>
-          <p:cNvPr id="36" name="Animated marker 4-4"/>
+          <p:cNvPr id="50" name="Animated marker 4-4"/>
           <p:cNvSpPr/>
           <p:nvPr/>
         </p:nvSpPr>
@@ -15557,7 +16232,7 @@
       </p:sp>
       <p:sp>
         <p:nvSpPr>
-          <p:cNvPr id="37" name="Animated marker 4-5"/>
+          <p:cNvPr id="51" name="Animated marker 4-5"/>
           <p:cNvSpPr/>
           <p:nvPr/>
         </p:nvSpPr>
@@ -15600,7 +16275,7 @@
       </p:sp>
       <p:sp>
         <p:nvSpPr>
-          <p:cNvPr id="38" name="Animated marker 4-6"/>
+          <p:cNvPr id="52" name="Animated marker 4-6"/>
           <p:cNvSpPr/>
           <p:nvPr/>
         </p:nvSpPr>
@@ -15643,7 +16318,7 @@
       </p:sp>
       <p:sp>
         <p:nvSpPr>
-          <p:cNvPr id="39" name="Animated marker 4-7"/>
+          <p:cNvPr id="53" name="Animated marker 4-7"/>
           <p:cNvSpPr/>
           <p:nvPr/>
         </p:nvSpPr>
@@ -15686,7 +16361,7 @@
       </p:sp>
       <p:sp>
         <p:nvSpPr>
-          <p:cNvPr id="40" name="Animated marker 4-8"/>
+          <p:cNvPr id="54" name="Animated marker 4-8"/>
           <p:cNvSpPr/>
           <p:nvPr/>
         </p:nvSpPr>
@@ -15729,7 +16404,7 @@
       </p:sp>
       <p:sp>
         <p:nvSpPr>
-          <p:cNvPr id="41" name="Animated marker 4-9"/>
+          <p:cNvPr id="55" name="Animated marker 4-9"/>
           <p:cNvSpPr/>
           <p:nvPr/>
         </p:nvSpPr>
@@ -15772,7 +16447,7 @@
       </p:sp>
       <p:sp>
         <p:nvSpPr>
-          <p:cNvPr id="42" name="Animated marker 4-10"/>
+          <p:cNvPr id="56" name="Animated marker 4-10"/>
           <p:cNvSpPr/>
           <p:nvPr/>
         </p:nvSpPr>
@@ -15815,7 +16490,7 @@
       </p:sp>
       <p:sp>
         <p:nvSpPr>
-          <p:cNvPr id="43" name="Animated marker 4-11"/>
+          <p:cNvPr id="57" name="Animated marker 4-11"/>
           <p:cNvSpPr/>
           <p:nvPr/>
         </p:nvSpPr>
@@ -15858,7 +16533,7 @@
       </p:sp>
       <p:sp>
         <p:nvSpPr>
-          <p:cNvPr id="44" name="Animated marker 4-12"/>
+          <p:cNvPr id="58" name="Animated marker 4-12"/>
           <p:cNvSpPr/>
           <p:nvPr/>
         </p:nvSpPr>
@@ -15901,7 +16576,7 @@
       </p:sp>
       <p:sp>
         <p:nvSpPr>
-          <p:cNvPr id="45" name="Animated marker 4-13"/>
+          <p:cNvPr id="59" name="Animated marker 4-13"/>
           <p:cNvSpPr/>
           <p:nvPr/>
         </p:nvSpPr>
@@ -15987,7 +16662,7 @@
                                           </p:stCondLst>
                                         </p:cTn>
                                         <p:tgtEl>
-                                          <p:spTgt spid="32"/>
+                                          <p:spTgt spid="46"/>
                                         </p:tgtEl>
                                         <p:attrNameLst>
                                           <p:attrName>style.visibility</p:attrName>
@@ -16001,7 +16676,7 @@
                                       <p:cBhvr>
                                         <p:cTn id="7" dur="450"/>
                                         <p:tgtEl>
-                                          <p:spTgt spid="32"/>
+                                          <p:spTgt spid="46"/>
                                         </p:tgtEl>
                                       </p:cBhvr>
                                     </p:animEffect>
@@ -16022,7 +16697,7 @@
                                           </p:stCondLst>
                                         </p:cTn>
                                         <p:tgtEl>
-                                          <p:spTgt spid="33"/>
+                                          <p:spTgt spid="47"/>
                                         </p:tgtEl>
                                         <p:attrNameLst>
                                           <p:attrName>style.visibility</p:attrName>
@@ -16036,7 +16711,7 @@
                                       <p:cBhvr>
                                         <p:cTn id="10" dur="450"/>
                                         <p:tgtEl>
-                                          <p:spTgt spid="33"/>
+                                          <p:spTgt spid="47"/>
                                         </p:tgtEl>
                                       </p:cBhvr>
                                     </p:animEffect>
@@ -16057,7 +16732,7 @@
                                           </p:stCondLst>
                                         </p:cTn>
                                         <p:tgtEl>
-                                          <p:spTgt spid="34"/>
+                                          <p:spTgt spid="48"/>
                                         </p:tgtEl>
                                         <p:attrNameLst>
                                           <p:attrName>style.visibility</p:attrName>
@@ -16071,7 +16746,7 @@
                                       <p:cBhvr>
                                         <p:cTn id="13" dur="300"/>
                                         <p:tgtEl>
-                                          <p:spTgt spid="34"/>
+                                          <p:spTgt spid="48"/>
                                         </p:tgtEl>
                                       </p:cBhvr>
                                     </p:animEffect>
@@ -16092,7 +16767,7 @@
                                           </p:stCondLst>
                                         </p:cTn>
                                         <p:tgtEl>
-                                          <p:spTgt spid="35"/>
+                                          <p:spTgt spid="49"/>
                                         </p:tgtEl>
                                         <p:attrNameLst>
                                           <p:attrName>style.visibility</p:attrName>
@@ -16106,7 +16781,7 @@
                                       <p:cBhvr>
                                         <p:cTn id="16" dur="450"/>
                                         <p:tgtEl>
-                                          <p:spTgt spid="35"/>
+                                          <p:spTgt spid="49"/>
                                         </p:tgtEl>
                                       </p:cBhvr>
                                     </p:animEffect>
@@ -16127,7 +16802,7 @@
                                           </p:stCondLst>
                                         </p:cTn>
                                         <p:tgtEl>
-                                          <p:spTgt spid="36"/>
+                                          <p:spTgt spid="50"/>
                                         </p:tgtEl>
                                         <p:attrNameLst>
                                           <p:attrName>style.visibility</p:attrName>
@@ -16141,7 +16816,7 @@
                                       <p:cBhvr>
                                         <p:cTn id="19" dur="450"/>
                                         <p:tgtEl>
-                                          <p:spTgt spid="36"/>
+                                          <p:spTgt spid="50"/>
                                         </p:tgtEl>
                                       </p:cBhvr>
                                     </p:animEffect>
@@ -16162,7 +16837,7 @@
                                           </p:stCondLst>
                                         </p:cTn>
                                         <p:tgtEl>
-                                          <p:spTgt spid="37"/>
+                                          <p:spTgt spid="51"/>
                                         </p:tgtEl>
                                         <p:attrNameLst>
                                           <p:attrName>style.visibility</p:attrName>
@@ -16176,7 +16851,7 @@
                                       <p:cBhvr>
                                         <p:cTn id="22" dur="300"/>
                                         <p:tgtEl>
-                                          <p:spTgt spid="37"/>
+                                          <p:spTgt spid="51"/>
                                         </p:tgtEl>
                                       </p:cBhvr>
                                     </p:animEffect>
@@ -16197,7 +16872,7 @@
                                           </p:stCondLst>
                                         </p:cTn>
                                         <p:tgtEl>
-                                          <p:spTgt spid="38"/>
+                                          <p:spTgt spid="52"/>
                                         </p:tgtEl>
                                         <p:attrNameLst>
                                           <p:attrName>style.visibility</p:attrName>
@@ -16211,7 +16886,7 @@
                                       <p:cBhvr>
                                         <p:cTn id="25" dur="300"/>
                                         <p:tgtEl>
-                                          <p:spTgt spid="38"/>
+                                          <p:spTgt spid="52"/>
                                         </p:tgtEl>
                                       </p:cBhvr>
                                     </p:animEffect>
@@ -16232,7 +16907,7 @@
                                           </p:stCondLst>
                                         </p:cTn>
                                         <p:tgtEl>
-                                          <p:spTgt spid="39"/>
+                                          <p:spTgt spid="53"/>
                                         </p:tgtEl>
                                         <p:attrNameLst>
                                           <p:attrName>style.visibility</p:attrName>
@@ -16246,7 +16921,7 @@
                                       <p:cBhvr>
                                         <p:cTn id="28" dur="300"/>
                                         <p:tgtEl>
-                                          <p:spTgt spid="39"/>
+                                          <p:spTgt spid="53"/>
                                         </p:tgtEl>
                                       </p:cBhvr>
                                     </p:animEffect>
@@ -16267,7 +16942,7 @@
                                           </p:stCondLst>
                                         </p:cTn>
                                         <p:tgtEl>
-                                          <p:spTgt spid="40"/>
+                                          <p:spTgt spid="54"/>
                                         </p:tgtEl>
                                         <p:attrNameLst>
                                           <p:attrName>style.visibility</p:attrName>
@@ -16281,7 +16956,7 @@
                                       <p:cBhvr>
                                         <p:cTn id="31" dur="450"/>
                                         <p:tgtEl>
-                                          <p:spTgt spid="40"/>
+                                          <p:spTgt spid="54"/>
                                         </p:tgtEl>
                                       </p:cBhvr>
                                     </p:animEffect>
@@ -16302,7 +16977,7 @@
                                           </p:stCondLst>
                                         </p:cTn>
                                         <p:tgtEl>
-                                          <p:spTgt spid="41"/>
+                                          <p:spTgt spid="55"/>
                                         </p:tgtEl>
                                         <p:attrNameLst>
                                           <p:attrName>style.visibility</p:attrName>
@@ -16316,7 +16991,7 @@
                                       <p:cBhvr>
                                         <p:cTn id="34" dur="450"/>
                                         <p:tgtEl>
-                                          <p:spTgt spid="41"/>
+                                          <p:spTgt spid="55"/>
                                         </p:tgtEl>
                                       </p:cBhvr>
                                     </p:animEffect>
@@ -16337,7 +17012,7 @@
                                           </p:stCondLst>
                                         </p:cTn>
                                         <p:tgtEl>
-                                          <p:spTgt spid="42"/>
+                                          <p:spTgt spid="56"/>
                                         </p:tgtEl>
                                         <p:attrNameLst>
                                           <p:attrName>style.visibility</p:attrName>
@@ -16351,7 +17026,7 @@
                                       <p:cBhvr>
                                         <p:cTn id="37" dur="300"/>
                                         <p:tgtEl>
-                                          <p:spTgt spid="42"/>
+                                          <p:spTgt spid="56"/>
                                         </p:tgtEl>
                                       </p:cBhvr>
                                     </p:animEffect>
@@ -16372,7 +17047,7 @@
                                           </p:stCondLst>
                                         </p:cTn>
                                         <p:tgtEl>
-                                          <p:spTgt spid="43"/>
+                                          <p:spTgt spid="57"/>
                                         </p:tgtEl>
                                         <p:attrNameLst>
                                           <p:attrName>style.visibility</p:attrName>
@@ -16386,7 +17061,7 @@
                                       <p:cBhvr>
                                         <p:cTn id="40" dur="300"/>
                                         <p:tgtEl>
-                                          <p:spTgt spid="43"/>
+                                          <p:spTgt spid="57"/>
                                         </p:tgtEl>
                                       </p:cBhvr>
                                     </p:animEffect>
@@ -16407,7 +17082,7 @@
                                           </p:stCondLst>
                                         </p:cTn>
                                         <p:tgtEl>
-                                          <p:spTgt spid="44"/>
+                                          <p:spTgt spid="58"/>
                                         </p:tgtEl>
                                         <p:attrNameLst>
                                           <p:attrName>style.visibility</p:attrName>
@@ -16421,7 +17096,7 @@
                                       <p:cBhvr>
                                         <p:cTn id="43" dur="300"/>
                                         <p:tgtEl>
-                                          <p:spTgt spid="44"/>
+                                          <p:spTgt spid="58"/>
                                         </p:tgtEl>
                                       </p:cBhvr>
                                     </p:animEffect>
@@ -16442,7 +17117,7 @@
                                           </p:stCondLst>
                                         </p:cTn>
                                         <p:tgtEl>
-                                          <p:spTgt spid="45"/>
+                                          <p:spTgt spid="59"/>
                                         </p:tgtEl>
                                         <p:attrNameLst>
                                           <p:attrName>style.visibility</p:attrName>
@@ -16456,7 +17131,7 @@
                                       <p:cBhvr>
                                         <p:cTn id="46" dur="300"/>
                                         <p:tgtEl>
-                                          <p:spTgt spid="45"/>
+                                          <p:spTgt spid="59"/>
                                         </p:tgtEl>
                                       </p:cBhvr>
                                     </p:animEffect>
@@ -16477,7 +17152,7 @@
                                           </p:stCondLst>
                                         </p:cTn>
                                         <p:tgtEl>
-                                          <p:spTgt spid="32"/>
+                                          <p:spTgt spid="46"/>
                                         </p:tgtEl>
                                         <p:attrNameLst>
                                           <p:attrName>style.visibility</p:attrName>
@@ -16491,7 +17166,7 @@
                                       <p:cBhvr>
                                         <p:cTn id="49" dur="450"/>
                                         <p:tgtEl>
-                                          <p:spTgt spid="32"/>
+                                          <p:spTgt spid="46"/>
                                         </p:tgtEl>
                                       </p:cBhvr>
                                     </p:animEffect>
@@ -16512,7 +17187,7 @@
                                           </p:stCondLst>
                                         </p:cTn>
                                         <p:tgtEl>
-                                          <p:spTgt spid="33"/>
+                                          <p:spTgt spid="47"/>
                                         </p:tgtEl>
                                         <p:attrNameLst>
                                           <p:attrName>style.visibility</p:attrName>
@@ -16526,7 +17201,7 @@
                                       <p:cBhvr>
                                         <p:cTn id="52" dur="450"/>
                                         <p:tgtEl>
-                                          <p:spTgt spid="33"/>
+                                          <p:spTgt spid="47"/>
                                         </p:tgtEl>
                                       </p:cBhvr>
                                     </p:animEffect>
@@ -16547,7 +17222,7 @@
                                           </p:stCondLst>
                                         </p:cTn>
                                         <p:tgtEl>
-                                          <p:spTgt spid="34"/>
+                                          <p:spTgt spid="48"/>
                                         </p:tgtEl>
                                         <p:attrNameLst>
                                           <p:attrName>style.visibility</p:attrName>
@@ -16561,7 +17236,7 @@
                                       <p:cBhvr>
                                         <p:cTn id="55" dur="300"/>
                                         <p:tgtEl>
-                                          <p:spTgt spid="34"/>
+                                          <p:spTgt spid="48"/>
                                         </p:tgtEl>
                                       </p:cBhvr>
                                     </p:animEffect>
@@ -16582,7 +17257,7 @@
                                           </p:stCondLst>
                                         </p:cTn>
                                         <p:tgtEl>
-                                          <p:spTgt spid="35"/>
+                                          <p:spTgt spid="49"/>
                                         </p:tgtEl>
                                         <p:attrNameLst>
                                           <p:attrName>style.visibility</p:attrName>
@@ -16596,7 +17271,7 @@
                                       <p:cBhvr>
                                         <p:cTn id="58" dur="300"/>
                                         <p:tgtEl>
-                                          <p:spTgt spid="35"/>
+                                          <p:spTgt spid="49"/>
                                         </p:tgtEl>
                                       </p:cBhvr>
                                     </p:animEffect>
@@ -16617,7 +17292,7 @@
                                           </p:stCondLst>
                                         </p:cTn>
                                         <p:tgtEl>
-                                          <p:spTgt spid="36"/>
+                                          <p:spTgt spid="50"/>
                                         </p:tgtEl>
                                         <p:attrNameLst>
                                           <p:attrName>style.visibility</p:attrName>
@@ -16631,7 +17306,7 @@
                                       <p:cBhvr>
                                         <p:cTn id="61" dur="450"/>
                                         <p:tgtEl>
-                                          <p:spTgt spid="36"/>
+                                          <p:spTgt spid="50"/>
                                         </p:tgtEl>
                                       </p:cBhvr>
                                     </p:animEffect>
@@ -16652,7 +17327,7 @@
                                           </p:stCondLst>
                                         </p:cTn>
                                         <p:tgtEl>
-                                          <p:spTgt spid="37"/>
+                                          <p:spTgt spid="51"/>
                                         </p:tgtEl>
                                         <p:attrNameLst>
                                           <p:attrName>style.visibility</p:attrName>
@@ -16666,7 +17341,7 @@
                                       <p:cBhvr>
                                         <p:cTn id="64" dur="450"/>
                                         <p:tgtEl>
-                                          <p:spTgt spid="37"/>
+                                          <p:spTgt spid="51"/>
                                         </p:tgtEl>
                                       </p:cBhvr>
                                     </p:animEffect>
@@ -16687,7 +17362,7 @@
                                           </p:stCondLst>
                                         </p:cTn>
                                         <p:tgtEl>
-                                          <p:spTgt spid="38"/>
+                                          <p:spTgt spid="52"/>
                                         </p:tgtEl>
                                         <p:attrNameLst>
                                           <p:attrName>style.visibility</p:attrName>
@@ -16701,7 +17376,7 @@
                                       <p:cBhvr>
                                         <p:cTn id="67" dur="300"/>
                                         <p:tgtEl>
-                                          <p:spTgt spid="38"/>
+                                          <p:spTgt spid="52"/>
                                         </p:tgtEl>
                                       </p:cBhvr>
                                     </p:animEffect>
@@ -16722,7 +17397,7 @@
                                           </p:stCondLst>
                                         </p:cTn>
                                         <p:tgtEl>
-                                          <p:spTgt spid="39"/>
+                                          <p:spTgt spid="53"/>
                                         </p:tgtEl>
                                         <p:attrNameLst>
                                           <p:attrName>style.visibility</p:attrName>
@@ -16736,7 +17411,7 @@
                                       <p:cBhvr>
                                         <p:cTn id="70" dur="300"/>
                                         <p:tgtEl>
-                                          <p:spTgt spid="39"/>
+                                          <p:spTgt spid="53"/>
                                         </p:tgtEl>
                                       </p:cBhvr>
                                     </p:animEffect>
@@ -16757,7 +17432,7 @@
                                           </p:stCondLst>
                                         </p:cTn>
                                         <p:tgtEl>
-                                          <p:spTgt spid="40"/>
+                                          <p:spTgt spid="54"/>
                                         </p:tgtEl>
                                         <p:attrNameLst>
                                           <p:attrName>style.visibility</p:attrName>
@@ -16771,7 +17446,7 @@
                                       <p:cBhvr>
                                         <p:cTn id="73" dur="300"/>
                                         <p:tgtEl>
-                                          <p:spTgt spid="40"/>
+                                          <p:spTgt spid="54"/>
                                         </p:tgtEl>
                                       </p:cBhvr>
                                     </p:animEffect>
@@ -16792,7 +17467,7 @@
                                           </p:stCondLst>
                                         </p:cTn>
                                         <p:tgtEl>
-                                          <p:spTgt spid="41"/>
+                                          <p:spTgt spid="55"/>
                                         </p:tgtEl>
                                         <p:attrNameLst>
                                           <p:attrName>style.visibility</p:attrName>
@@ -16806,7 +17481,7 @@
                                       <p:cBhvr>
                                         <p:cTn id="76" dur="300"/>
                                         <p:tgtEl>
-                                          <p:spTgt spid="41"/>
+                                          <p:spTgt spid="55"/>
                                         </p:tgtEl>
                                       </p:cBhvr>
                                     </p:animEffect>
@@ -16827,7 +17502,7 @@
                                           </p:stCondLst>
                                         </p:cTn>
                                         <p:tgtEl>
-                                          <p:spTgt spid="42"/>
+                                          <p:spTgt spid="56"/>
                                         </p:tgtEl>
                                         <p:attrNameLst>
                                           <p:attrName>style.visibility</p:attrName>
@@ -16841,7 +17516,7 @@
                                       <p:cBhvr>
                                         <p:cTn id="79" dur="450"/>
                                         <p:tgtEl>
-                                          <p:spTgt spid="42"/>
+                                          <p:spTgt spid="56"/>
                                         </p:tgtEl>
                                       </p:cBhvr>
                                     </p:animEffect>
@@ -16862,7 +17537,7 @@
                                           </p:stCondLst>
                                         </p:cTn>
                                         <p:tgtEl>
-                                          <p:spTgt spid="43"/>
+                                          <p:spTgt spid="57"/>
                                         </p:tgtEl>
                                         <p:attrNameLst>
                                           <p:attrName>style.visibility</p:attrName>
@@ -16876,7 +17551,7 @@
                                       <p:cBhvr>
                                         <p:cTn id="82" dur="450"/>
                                         <p:tgtEl>
-                                          <p:spTgt spid="43"/>
+                                          <p:spTgt spid="57"/>
                                         </p:tgtEl>
                                       </p:cBhvr>
                                     </p:animEffect>
@@ -16897,7 +17572,7 @@
                                           </p:stCondLst>
                                         </p:cTn>
                                         <p:tgtEl>
-                                          <p:spTgt spid="44"/>
+                                          <p:spTgt spid="58"/>
                                         </p:tgtEl>
                                         <p:attrNameLst>
                                           <p:attrName>style.visibility</p:attrName>
@@ -16911,7 +17586,7 @@
                                       <p:cBhvr>
                                         <p:cTn id="85" dur="300"/>
                                         <p:tgtEl>
-                                          <p:spTgt spid="44"/>
+                                          <p:spTgt spid="58"/>
                                         </p:tgtEl>
                                       </p:cBhvr>
                                     </p:animEffect>
@@ -16932,7 +17607,7 @@
                                           </p:stCondLst>
                                         </p:cTn>
                                         <p:tgtEl>
-                                          <p:spTgt spid="45"/>
+                                          <p:spTgt spid="59"/>
                                         </p:tgtEl>
                                         <p:attrNameLst>
                                           <p:attrName>style.visibility</p:attrName>
@@ -16946,7 +17621,7 @@
                                       <p:cBhvr>
                                         <p:cTn id="88" dur="300"/>
                                         <p:tgtEl>
-                                          <p:spTgt spid="45"/>
+                                          <p:spTgt spid="59"/>
                                         </p:tgtEl>
                                       </p:cBhvr>
                                     </p:animEffect>
@@ -16967,7 +17642,7 @@
                                           </p:stCondLst>
                                         </p:cTn>
                                         <p:tgtEl>
-                                          <p:spTgt spid="32"/>
+                                          <p:spTgt spid="46"/>
                                         </p:tgtEl>
                                         <p:attrNameLst>
                                           <p:attrName>style.visibility</p:attrName>
@@ -16981,7 +17656,7 @@
                                       <p:cBhvr>
                                         <p:cTn id="91" dur="300"/>
                                         <p:tgtEl>
-                                          <p:spTgt spid="32"/>
+                                          <p:spTgt spid="46"/>
                                         </p:tgtEl>
                                       </p:cBhvr>
                                     </p:animEffect>
@@ -17002,7 +17677,7 @@
                                           </p:stCondLst>
                                         </p:cTn>
                                         <p:tgtEl>
-                                          <p:spTgt spid="33"/>
+                                          <p:spTgt spid="47"/>
                                         </p:tgtEl>
                                         <p:attrNameLst>
                                           <p:attrName>style.visibility</p:attrName>
@@ -17016,7 +17691,7 @@
                                       <p:cBhvr>
                                         <p:cTn id="94" dur="450"/>
                                         <p:tgtEl>
-                                          <p:spTgt spid="33"/>
+                                          <p:spTgt spid="47"/>
                                         </p:tgtEl>
                                       </p:cBhvr>
                                     </p:animEffect>
@@ -17037,7 +17712,7 @@
                                           </p:stCondLst>
                                         </p:cTn>
                                         <p:tgtEl>
-                                          <p:spTgt spid="34"/>
+                                          <p:spTgt spid="48"/>
                                         </p:tgtEl>
                                         <p:attrNameLst>
                                           <p:attrName>style.visibility</p:attrName>
@@ -17051,7 +17726,7 @@
                                       <p:cBhvr>
                                         <p:cTn id="97" dur="450"/>
                                         <p:tgtEl>
-                                          <p:spTgt spid="34"/>
+                                          <p:spTgt spid="48"/>
                                         </p:tgtEl>
                                       </p:cBhvr>
                                     </p:animEffect>
@@ -17072,7 +17747,7 @@
                                           </p:stCondLst>
                                         </p:cTn>
                                         <p:tgtEl>
-                                          <p:spTgt spid="35"/>
+                                          <p:spTgt spid="49"/>
                                         </p:tgtEl>
                                         <p:attrNameLst>
                                           <p:attrName>style.visibility</p:attrName>
@@ -17086,7 +17761,7 @@
                                       <p:cBhvr>
                                         <p:cTn id="100" dur="300"/>
                                         <p:tgtEl>
-                                          <p:spTgt spid="35"/>
+                                          <p:spTgt spid="49"/>
                                         </p:tgtEl>
                                       </p:cBhvr>
                                     </p:animEffect>
@@ -17107,7 +17782,7 @@
                                           </p:stCondLst>
                                         </p:cTn>
                                         <p:tgtEl>
-                                          <p:spTgt spid="36"/>
+                                          <p:spTgt spid="50"/>
                                         </p:tgtEl>
                                         <p:attrNameLst>
                                           <p:attrName>style.visibility</p:attrName>
@@ -17121,7 +17796,7 @@
                                       <p:cBhvr>
                                         <p:cTn id="103" dur="300"/>
                                         <p:tgtEl>
-                                          <p:spTgt spid="36"/>
+                                          <p:spTgt spid="50"/>
                                         </p:tgtEl>
                                       </p:cBhvr>
                                     </p:animEffect>
@@ -17142,7 +17817,7 @@
                                           </p:stCondLst>
                                         </p:cTn>
                                         <p:tgtEl>
-                                          <p:spTgt spid="37"/>
+                                          <p:spTgt spid="51"/>
                                         </p:tgtEl>
                                         <p:attrNameLst>
                                           <p:attrName>style.visibility</p:attrName>
@@ -17156,7 +17831,7 @@
                                       <p:cBhvr>
                                         <p:cTn id="106" dur="300"/>
                                         <p:tgtEl>
-                                          <p:spTgt spid="37"/>
+                                          <p:spTgt spid="51"/>
                                         </p:tgtEl>
                                       </p:cBhvr>
                                     </p:animEffect>
@@ -17177,7 +17852,7 @@
                                           </p:stCondLst>
                                         </p:cTn>
                                         <p:tgtEl>
-                                          <p:spTgt spid="38"/>
+                                          <p:spTgt spid="52"/>
                                         </p:tgtEl>
                                         <p:attrNameLst>
                                           <p:attrName>style.visibility</p:attrName>
@@ -17191,7 +17866,7 @@
                                       <p:cBhvr>
                                         <p:cTn id="109" dur="300"/>
                                         <p:tgtEl>
-                                          <p:spTgt spid="38"/>
+                                          <p:spTgt spid="52"/>
                                         </p:tgtEl>
                                       </p:cBhvr>
                                     </p:animEffect>
@@ -17212,7 +17887,7 @@
                                           </p:stCondLst>
                                         </p:cTn>
                                         <p:tgtEl>
-                                          <p:spTgt spid="39"/>
+                                          <p:spTgt spid="53"/>
                                         </p:tgtEl>
                                         <p:attrNameLst>
                                           <p:attrName>style.visibility</p:attrName>
@@ -17226,7 +17901,7 @@
                                       <p:cBhvr>
                                         <p:cTn id="112" dur="600"/>
                                         <p:tgtEl>
-                                          <p:spTgt spid="39"/>
+                                          <p:spTgt spid="53"/>
                                         </p:tgtEl>
                                       </p:cBhvr>
                                     </p:animEffect>
@@ -17247,7 +17922,7 @@
                                           </p:stCondLst>
                                         </p:cTn>
                                         <p:tgtEl>
-                                          <p:spTgt spid="40"/>
+                                          <p:spTgt spid="54"/>
                                         </p:tgtEl>
                                         <p:attrNameLst>
                                           <p:attrName>style.visibility</p:attrName>
@@ -17261,7 +17936,7 @@
                                       <p:cBhvr>
                                         <p:cTn id="115" dur="600"/>
                                         <p:tgtEl>
-                                          <p:spTgt spid="40"/>
+                                          <p:spTgt spid="54"/>
                                         </p:tgtEl>
                                       </p:cBhvr>
                                     </p:animEffect>
@@ -17282,7 +17957,7 @@
                                           </p:stCondLst>
                                         </p:cTn>
                                         <p:tgtEl>
-                                          <p:spTgt spid="41"/>
+                                          <p:spTgt spid="55"/>
                                         </p:tgtEl>
                                         <p:attrNameLst>
                                           <p:attrName>style.visibility</p:attrName>
@@ -17296,7 +17971,7 @@
                                       <p:cBhvr>
                                         <p:cTn id="118" dur="600"/>
                                         <p:tgtEl>
-                                          <p:spTgt spid="41"/>
+                                          <p:spTgt spid="55"/>
                                         </p:tgtEl>
                                       </p:cBhvr>
                                     </p:animEffect>
@@ -17317,7 +17992,7 @@
                                           </p:stCondLst>
                                         </p:cTn>
                                         <p:tgtEl>
-                                          <p:spTgt spid="42"/>
+                                          <p:spTgt spid="56"/>
                                         </p:tgtEl>
                                         <p:attrNameLst>
                                           <p:attrName>style.visibility</p:attrName>
@@ -17331,7 +18006,7 @@
                                       <p:cBhvr>
                                         <p:cTn id="121" dur="600"/>
                                         <p:tgtEl>
-                                          <p:spTgt spid="42"/>
+                                          <p:spTgt spid="56"/>
                                         </p:tgtEl>
                                       </p:cBhvr>
                                     </p:animEffect>
@@ -17352,7 +18027,7 @@
                                           </p:stCondLst>
                                         </p:cTn>
                                         <p:tgtEl>
-                                          <p:spTgt spid="43"/>
+                                          <p:spTgt spid="57"/>
                                         </p:tgtEl>
                                         <p:attrNameLst>
                                           <p:attrName>style.visibility</p:attrName>
@@ -17366,7 +18041,7 @@
                                       <p:cBhvr>
                                         <p:cTn id="124" dur="600"/>
                                         <p:tgtEl>
-                                          <p:spTgt spid="43"/>
+                                          <p:spTgt spid="57"/>
                                         </p:tgtEl>
                                       </p:cBhvr>
                                     </p:animEffect>
@@ -17387,7 +18062,7 @@
                                           </p:stCondLst>
                                         </p:cTn>
                                         <p:tgtEl>
-                                          <p:spTgt spid="44"/>
+                                          <p:spTgt spid="58"/>
                                         </p:tgtEl>
                                         <p:attrNameLst>
                                           <p:attrName>style.visibility</p:attrName>
@@ -17401,7 +18076,7 @@
                                       <p:cBhvr>
                                         <p:cTn id="127" dur="600"/>
                                         <p:tgtEl>
-                                          <p:spTgt spid="44"/>
+                                          <p:spTgt spid="58"/>
                                         </p:tgtEl>
                                       </p:cBhvr>
                                     </p:animEffect>
@@ -17422,7 +18097,7 @@
                                           </p:stCondLst>
                                         </p:cTn>
                                         <p:tgtEl>
-                                          <p:spTgt spid="45"/>
+                                          <p:spTgt spid="59"/>
                                         </p:tgtEl>
                                         <p:attrNameLst>
                                           <p:attrName>style.visibility</p:attrName>
@@ -17436,7 +18111,7 @@
                                       <p:cBhvr>
                                         <p:cTn id="130" dur="600"/>
                                         <p:tgtEl>
-                                          <p:spTgt spid="45"/>
+                                          <p:spTgt spid="59"/>
                                         </p:tgtEl>
                                       </p:cBhvr>
                                     </p:animEffect>
@@ -17457,7 +18132,7 @@
                                           </p:stCondLst>
                                         </p:cTn>
                                         <p:tgtEl>
-                                          <p:spTgt spid="32"/>
+                                          <p:spTgt spid="46"/>
                                         </p:tgtEl>
                                         <p:attrNameLst>
                                           <p:attrName>style.visibility</p:attrName>
@@ -17471,7 +18146,7 @@
                                       <p:cBhvr>
                                         <p:cTn id="133" dur="120"/>
                                         <p:tgtEl>
-                                          <p:spTgt spid="32"/>
+                                          <p:spTgt spid="46"/>
                                         </p:tgtEl>
                                       </p:cBhvr>
                                     </p:animEffect>
@@ -17492,7 +18167,7 @@
                                           </p:stCondLst>
                                         </p:cTn>
                                         <p:tgtEl>
-                                          <p:spTgt spid="32"/>
+                                          <p:spTgt spid="46"/>
                                         </p:tgtEl>
                                         <p:attrNameLst>
                                           <p:attrName>style.visibility</p:attrName>
@@ -17510,7 +18185,7 @@
                                           </p:stCondLst>
                                         </p:cTn>
                                         <p:tgtEl>
-                                          <p:spTgt spid="32"/>
+                                          <p:spTgt spid="46"/>
                                         </p:tgtEl>
                                         <p:attrNameLst>
                                           <p:attrName>ppt_x</p:attrName>
@@ -17535,7 +18210,7 @@
                                           </p:stCondLst>
                                         </p:cTn>
                                         <p:tgtEl>
-                                          <p:spTgt spid="33"/>
+                                          <p:spTgt spid="47"/>
                                         </p:tgtEl>
                                         <p:attrNameLst>
                                           <p:attrName>style.visibility</p:attrName>
@@ -17549,7 +18224,7 @@
                                       <p:cBhvr>
                                         <p:cTn id="139" dur="120"/>
                                         <p:tgtEl>
-                                          <p:spTgt spid="33"/>
+                                          <p:spTgt spid="47"/>
                                         </p:tgtEl>
                                       </p:cBhvr>
                                     </p:animEffect>
@@ -17570,7 +18245,7 @@
                                           </p:stCondLst>
                                         </p:cTn>
                                         <p:tgtEl>
-                                          <p:spTgt spid="33"/>
+                                          <p:spTgt spid="47"/>
                                         </p:tgtEl>
                                         <p:attrNameLst>
                                           <p:attrName>style.visibility</p:attrName>
@@ -17588,7 +18263,7 @@
                                           </p:stCondLst>
                                         </p:cTn>
                                         <p:tgtEl>
-                                          <p:spTgt spid="33"/>
+                                          <p:spTgt spid="47"/>
                                         </p:tgtEl>
                                         <p:attrNameLst>
                                           <p:attrName>ppt_x</p:attrName>
@@ -17613,7 +18288,7 @@
                                           </p:stCondLst>
                                         </p:cTn>
                                         <p:tgtEl>
-                                          <p:spTgt spid="34"/>
+                                          <p:spTgt spid="48"/>
                                         </p:tgtEl>
                                         <p:attrNameLst>
                                           <p:attrName>style.visibility</p:attrName>
@@ -17627,7 +18302,7 @@
                                       <p:cBhvr>
                                         <p:cTn id="145" dur="120"/>
                                         <p:tgtEl>
-                                          <p:spTgt spid="34"/>
+                                          <p:spTgt spid="48"/>
                                         </p:tgtEl>
                                       </p:cBhvr>
                                     </p:animEffect>
@@ -17648,7 +18323,7 @@
                                           </p:stCondLst>
                                         </p:cTn>
                                         <p:tgtEl>
-                                          <p:spTgt spid="34"/>
+                                          <p:spTgt spid="48"/>
                                         </p:tgtEl>
                                         <p:attrNameLst>
                                           <p:attrName>style.visibility</p:attrName>
@@ -17666,7 +18341,7 @@
                                           </p:stCondLst>
                                         </p:cTn>
                                         <p:tgtEl>
-                                          <p:spTgt spid="34"/>
+                                          <p:spTgt spid="48"/>
                                         </p:tgtEl>
                                         <p:attrNameLst>
                                           <p:attrName>ppt_x</p:attrName>
@@ -17691,7 +18366,7 @@
                                           </p:stCondLst>
                                         </p:cTn>
                                         <p:tgtEl>
-                                          <p:spTgt spid="35"/>
+                                          <p:spTgt spid="49"/>
                                         </p:tgtEl>
                                         <p:attrNameLst>
                                           <p:attrName>style.visibility</p:attrName>
@@ -17705,7 +18380,7 @@
                                       <p:cBhvr>
                                         <p:cTn id="151" dur="120"/>
                                         <p:tgtEl>
-                                          <p:spTgt spid="35"/>
+                                          <p:spTgt spid="49"/>
                                         </p:tgtEl>
                                       </p:cBhvr>
                                     </p:animEffect>
@@ -17726,7 +18401,7 @@
                                           </p:stCondLst>
                                         </p:cTn>
                                         <p:tgtEl>
-                                          <p:spTgt spid="35"/>
+                                          <p:spTgt spid="49"/>
                                         </p:tgtEl>
                                         <p:attrNameLst>
                                           <p:attrName>style.visibility</p:attrName>
@@ -17744,7 +18419,7 @@
                                           </p:stCondLst>
                                         </p:cTn>
                                         <p:tgtEl>
-                                          <p:spTgt spid="35"/>
+                                          <p:spTgt spid="49"/>
                                         </p:tgtEl>
                                         <p:attrNameLst>
                                           <p:attrName>ppt_x</p:attrName>
@@ -17769,7 +18444,7 @@
                                           </p:stCondLst>
                                         </p:cTn>
                                         <p:tgtEl>
-                                          <p:spTgt spid="36"/>
+                                          <p:spTgt spid="50"/>
                                         </p:tgtEl>
                                         <p:attrNameLst>
                                           <p:attrName>style.visibility</p:attrName>
@@ -17783,7 +18458,7 @@
                                       <p:cBhvr>
                                         <p:cTn id="157" dur="120"/>
                                         <p:tgtEl>
-                                          <p:spTgt spid="36"/>
+                                          <p:spTgt spid="50"/>
                                         </p:tgtEl>
                                       </p:cBhvr>
                                     </p:animEffect>
@@ -17804,7 +18479,7 @@
                                           </p:stCondLst>
                                         </p:cTn>
                                         <p:tgtEl>
-                                          <p:spTgt spid="36"/>
+                                          <p:spTgt spid="50"/>
                                         </p:tgtEl>
                                         <p:attrNameLst>
                                           <p:attrName>style.visibility</p:attrName>
@@ -17822,7 +18497,7 @@
                                           </p:stCondLst>
                                         </p:cTn>
                                         <p:tgtEl>
-                                          <p:spTgt spid="36"/>
+                                          <p:spTgt spid="50"/>
                                         </p:tgtEl>
                                         <p:attrNameLst>
                                           <p:attrName>ppt_x</p:attrName>
@@ -17847,7 +18522,7 @@
                                           </p:stCondLst>
                                         </p:cTn>
                                         <p:tgtEl>
-                                          <p:spTgt spid="37"/>
+                                          <p:spTgt spid="51"/>
                                         </p:tgtEl>
                                         <p:attrNameLst>
                                           <p:attrName>style.visibility</p:attrName>
@@ -17861,7 +18536,7 @@
                                       <p:cBhvr>
                                         <p:cTn id="163" dur="120"/>
                                         <p:tgtEl>
-                                          <p:spTgt spid="37"/>
+                                          <p:spTgt spid="51"/>
                                         </p:tgtEl>
                                       </p:cBhvr>
                                     </p:animEffect>
@@ -17882,7 +18557,7 @@
                                           </p:stCondLst>
                                         </p:cTn>
                                         <p:tgtEl>
-                                          <p:spTgt spid="37"/>
+                                          <p:spTgt spid="51"/>
                                         </p:tgtEl>
                                         <p:attrNameLst>
                                           <p:attrName>style.visibility</p:attrName>
@@ -17900,7 +18575,7 @@
                                           </p:stCondLst>
                                         </p:cTn>
                                         <p:tgtEl>
-                                          <p:spTgt spid="37"/>
+                                          <p:spTgt spid="51"/>
                                         </p:tgtEl>
                                         <p:attrNameLst>
                                           <p:attrName>ppt_x</p:attrName>
@@ -17925,7 +18600,7 @@
                                           </p:stCondLst>
                                         </p:cTn>
                                         <p:tgtEl>
-                                          <p:spTgt spid="38"/>
+                                          <p:spTgt spid="52"/>
                                         </p:tgtEl>
                                         <p:attrNameLst>
                                           <p:attrName>style.visibility</p:attrName>
@@ -17939,7 +18614,7 @@
                                       <p:cBhvr>
                                         <p:cTn id="169" dur="120"/>
                                         <p:tgtEl>
-                                          <p:spTgt spid="38"/>
+                                          <p:spTgt spid="52"/>
                                         </p:tgtEl>
                                       </p:cBhvr>
                                     </p:animEffect>
@@ -17960,7 +18635,7 @@
                                           </p:stCondLst>
                                         </p:cTn>
                                         <p:tgtEl>
-                                          <p:spTgt spid="38"/>
+                                          <p:spTgt spid="52"/>
                                         </p:tgtEl>
                                         <p:attrNameLst>
                                           <p:attrName>style.visibility</p:attrName>
@@ -17978,7 +18653,7 @@
                                           </p:stCondLst>
                                         </p:cTn>
                                         <p:tgtEl>
-                                          <p:spTgt spid="38"/>
+                                          <p:spTgt spid="52"/>
                                         </p:tgtEl>
                                         <p:attrNameLst>
                                           <p:attrName>ppt_x</p:attrName>
@@ -17999,7 +18674,7 @@
                                       <p:cBhvr>
                                         <p:cTn id="174" dur="120"/>
                                         <p:tgtEl>
-                                          <p:spTgt spid="32"/>
+                                          <p:spTgt spid="46"/>
                                         </p:tgtEl>
                                       </p:cBhvr>
                                     </p:animEffect>
@@ -18011,7 +18686,7 @@
                                           </p:stCondLst>
                                         </p:cTn>
                                         <p:tgtEl>
-                                          <p:spTgt spid="32"/>
+                                          <p:spTgt spid="46"/>
                                         </p:tgtEl>
                                         <p:attrNameLst>
                                           <p:attrName>style.visibility</p:attrName>
@@ -18034,7 +18709,7 @@
                                       <p:cBhvr>
                                         <p:cTn id="177" dur="120"/>
                                         <p:tgtEl>
-                                          <p:spTgt spid="33"/>
+                                          <p:spTgt spid="47"/>
                                         </p:tgtEl>
                                       </p:cBhvr>
                                     </p:animEffect>
@@ -18046,7 +18721,7 @@
                                           </p:stCondLst>
                                         </p:cTn>
                                         <p:tgtEl>
-                                          <p:spTgt spid="33"/>
+                                          <p:spTgt spid="47"/>
                                         </p:tgtEl>
                                         <p:attrNameLst>
                                           <p:attrName>style.visibility</p:attrName>
@@ -18069,7 +18744,7 @@
                                       <p:cBhvr>
                                         <p:cTn id="180" dur="120"/>
                                         <p:tgtEl>
-                                          <p:spTgt spid="34"/>
+                                          <p:spTgt spid="48"/>
                                         </p:tgtEl>
                                       </p:cBhvr>
                                     </p:animEffect>
@@ -18081,7 +18756,7 @@
                                           </p:stCondLst>
                                         </p:cTn>
                                         <p:tgtEl>
-                                          <p:spTgt spid="34"/>
+                                          <p:spTgt spid="48"/>
                                         </p:tgtEl>
                                         <p:attrNameLst>
                                           <p:attrName>style.visibility</p:attrName>
@@ -18104,7 +18779,7 @@
                                       <p:cBhvr>
                                         <p:cTn id="183" dur="120"/>
                                         <p:tgtEl>
-                                          <p:spTgt spid="35"/>
+                                          <p:spTgt spid="49"/>
                                         </p:tgtEl>
                                       </p:cBhvr>
                                     </p:animEffect>
@@ -18116,7 +18791,7 @@
                                           </p:stCondLst>
                                         </p:cTn>
                                         <p:tgtEl>
-                                          <p:spTgt spid="35"/>
+                                          <p:spTgt spid="49"/>
                                         </p:tgtEl>
                                         <p:attrNameLst>
                                           <p:attrName>style.visibility</p:attrName>
@@ -18139,7 +18814,7 @@
                                       <p:cBhvr>
                                         <p:cTn id="186" dur="120"/>
                                         <p:tgtEl>
-                                          <p:spTgt spid="36"/>
+                                          <p:spTgt spid="50"/>
                                         </p:tgtEl>
                                       </p:cBhvr>
                                     </p:animEffect>
@@ -18151,7 +18826,7 @@
                                           </p:stCondLst>
                                         </p:cTn>
                                         <p:tgtEl>
-                                          <p:spTgt spid="36"/>
+                                          <p:spTgt spid="50"/>
                                         </p:tgtEl>
                                         <p:attrNameLst>
                                           <p:attrName>style.visibility</p:attrName>
@@ -18174,7 +18849,7 @@
                                       <p:cBhvr>
                                         <p:cTn id="189" dur="120"/>
                                         <p:tgtEl>
-                                          <p:spTgt spid="37"/>
+                                          <p:spTgt spid="51"/>
                                         </p:tgtEl>
                                       </p:cBhvr>
                                     </p:animEffect>
@@ -18186,7 +18861,7 @@
                                           </p:stCondLst>
                                         </p:cTn>
                                         <p:tgtEl>
-                                          <p:spTgt spid="37"/>
+                                          <p:spTgt spid="51"/>
                                         </p:tgtEl>
                                         <p:attrNameLst>
                                           <p:attrName>style.visibility</p:attrName>
@@ -18209,7 +18884,7 @@
                                       <p:cBhvr>
                                         <p:cTn id="192" dur="120"/>
                                         <p:tgtEl>
-                                          <p:spTgt spid="38"/>
+                                          <p:spTgt spid="52"/>
                                         </p:tgtEl>
                                       </p:cBhvr>
                                     </p:animEffect>
@@ -18221,7 +18896,7 @@
                                           </p:stCondLst>
                                         </p:cTn>
                                         <p:tgtEl>
-                                          <p:spTgt spid="38"/>
+                                          <p:spTgt spid="52"/>
                                         </p:tgtEl>
                                         <p:attrNameLst>
                                           <p:attrName>style.visibility</p:attrName>

</xml_diff>